<commit_message>
chore: relatorios regerados com os blocos corrigidos
Os arquivos em data/reports/ estavam defasados em relacao ao codigo - o
digest gravado ainda trazia a coluna "Fundos" que o codigo ja havia
trocado por "Vitrine | Catalogo".

Efeito visivel das correcoes desta rodada: o deck passa a publicar a mesma
vitrine que o dashboard (XP 664, BTG 634, Itau 458, Inter 466 - antes ele
contava os restritos junto), e a serie mensal por casa fecha com o total da
casa em R$ 0,00 de diferenca.

Co-Authored-By: Claude Opus 5 <noreply@anthropic.com>
</commit_message>
<xml_diff>
--- a/data/reports/prateleiras-2026-09-20.pptx
+++ b/data/reports/prateleiras-2026-09-20.pptx
@@ -13,6 +13,7 @@
     <p:sldId id="261" r:id="rId12"/>
     <p:sldId id="262" r:id="rId13"/>
     <p:sldId id="263" r:id="rId14"/>
+    <p:sldId id="264" r:id="rId15"/>
   </p:sldIdLst>
   <p:sldSz cx="12191695" cy="6858000" type="screen4x3"/>
   <p:notesSz cx="6858000" cy="9144000"/>
@@ -3706,7 +3707,7 @@
                 </a:solidFill>
                 <a:latin typeface="Calibri"/>
               </a:rPr>
-              <a:t>catalogo: 6.604</a:t>
+              <a:t>catalogo: 6.618</a:t>
             </a:r>
           </a:p>
         </p:txBody>
@@ -4599,13 +4600,13 @@
                           </a:solidFill>
                           <a:latin typeface="Calibri"/>
                         </a:rPr>
-                        <a:t>84</a:t>
-                      </a:r>
-                    </a:p>
-                  </a:txBody>
-                  <a:tcPr>
-                    <a:solidFill>
-                      <a:srgbClr val="3987E5"/>
+                        <a:t>93</a:t>
+                      </a:r>
+                    </a:p>
+                  </a:txBody>
+                  <a:tcPr>
+                    <a:solidFill>
+                      <a:srgbClr val="184F95"/>
                     </a:solidFill>
                   </a:tcPr>
                 </a:tc>
@@ -4621,7 +4622,29 @@
                           </a:solidFill>
                           <a:latin typeface="Calibri"/>
                         </a:rPr>
-                        <a:t>109</a:t>
+                        <a:t>114</a:t>
+                      </a:r>
+                    </a:p>
+                  </a:txBody>
+                  <a:tcPr>
+                    <a:solidFill>
+                      <a:srgbClr val="0D366B"/>
+                    </a:solidFill>
+                  </a:tcPr>
+                </a:tc>
+                <a:tc>
+                  <a:txBody>
+                    <a:bodyPr wrap="square"/>
+                    <a:lstStyle/>
+                    <a:p>
+                      <a:r>
+                        <a:rPr sz="1000" b="0">
+                          <a:solidFill>
+                            <a:srgbClr val="FFFFFF"/>
+                          </a:solidFill>
+                          <a:latin typeface="Calibri"/>
+                        </a:rPr>
+                        <a:t>75</a:t>
                       </a:r>
                     </a:p>
                   </a:txBody>
@@ -4639,39 +4662,17 @@
                       <a:r>
                         <a:rPr sz="1000" b="0">
                           <a:solidFill>
-                            <a:srgbClr val="0B0B0B"/>
-                          </a:solidFill>
-                          <a:latin typeface="Calibri"/>
-                        </a:rPr>
-                        <a:t>4</a:t>
-                      </a:r>
-                    </a:p>
-                  </a:txBody>
-                  <a:tcPr>
-                    <a:solidFill>
-                      <a:srgbClr val="CDE2FB"/>
-                    </a:solidFill>
-                  </a:tcPr>
-                </a:tc>
-                <a:tc>
-                  <a:txBody>
-                    <a:bodyPr wrap="square"/>
-                    <a:lstStyle/>
-                    <a:p>
-                      <a:r>
-                        <a:rPr sz="1000" b="0">
-                          <a:solidFill>
                             <a:srgbClr val="FFFFFF"/>
                           </a:solidFill>
                           <a:latin typeface="Calibri"/>
                         </a:rPr>
-                        <a:t>89</a:t>
-                      </a:r>
-                    </a:p>
-                  </a:txBody>
-                  <a:tcPr>
-                    <a:solidFill>
-                      <a:srgbClr val="3987E5"/>
+                        <a:t>105</a:t>
+                      </a:r>
+                    </a:p>
+                  </a:txBody>
+                  <a:tcPr>
+                    <a:solidFill>
+                      <a:srgbClr val="0D366B"/>
                     </a:solidFill>
                   </a:tcPr>
                 </a:tc>
@@ -4711,79 +4712,79 @@
                           </a:solidFill>
                           <a:latin typeface="Calibri"/>
                         </a:rPr>
+                        <a:t>78</a:t>
+                      </a:r>
+                    </a:p>
+                  </a:txBody>
+                  <a:tcPr>
+                    <a:solidFill>
+                      <a:srgbClr val="256ABF"/>
+                    </a:solidFill>
+                  </a:tcPr>
+                </a:tc>
+                <a:tc>
+                  <a:txBody>
+                    <a:bodyPr wrap="square"/>
+                    <a:lstStyle/>
+                    <a:p>
+                      <a:r>
+                        <a:rPr sz="1000" b="0">
+                          <a:solidFill>
+                            <a:srgbClr val="FFFFFF"/>
+                          </a:solidFill>
+                          <a:latin typeface="Calibri"/>
+                        </a:rPr>
+                        <a:t>99</a:t>
+                      </a:r>
+                    </a:p>
+                  </a:txBody>
+                  <a:tcPr>
+                    <a:solidFill>
+                      <a:srgbClr val="0D366B"/>
+                    </a:solidFill>
+                  </a:tcPr>
+                </a:tc>
+                <a:tc>
+                  <a:txBody>
+                    <a:bodyPr wrap="square"/>
+                    <a:lstStyle/>
+                    <a:p>
+                      <a:r>
+                        <a:rPr sz="1000" b="0">
+                          <a:solidFill>
+                            <a:srgbClr val="FFFFFF"/>
+                          </a:solidFill>
+                          <a:latin typeface="Calibri"/>
+                        </a:rPr>
+                        <a:t>92</a:t>
+                      </a:r>
+                    </a:p>
+                  </a:txBody>
+                  <a:tcPr>
+                    <a:solidFill>
+                      <a:srgbClr val="184F95"/>
+                    </a:solidFill>
+                  </a:tcPr>
+                </a:tc>
+                <a:tc>
+                  <a:txBody>
+                    <a:bodyPr wrap="square"/>
+                    <a:lstStyle/>
+                    <a:p>
+                      <a:r>
+                        <a:rPr sz="1000" b="0">
+                          <a:solidFill>
+                            <a:srgbClr val="FFFFFF"/>
+                          </a:solidFill>
+                          <a:latin typeface="Calibri"/>
+                        </a:rPr>
                         <a:t>76</a:t>
                       </a:r>
                     </a:p>
                   </a:txBody>
                   <a:tcPr>
                     <a:solidFill>
-                      <a:srgbClr val="3987E5"/>
-                    </a:solidFill>
-                  </a:tcPr>
-                </a:tc>
-                <a:tc>
-                  <a:txBody>
-                    <a:bodyPr wrap="square"/>
-                    <a:lstStyle/>
-                    <a:p>
-                      <a:r>
-                        <a:rPr sz="1000" b="0">
-                          <a:solidFill>
-                            <a:srgbClr val="FFFFFF"/>
-                          </a:solidFill>
-                          <a:latin typeface="Calibri"/>
-                        </a:rPr>
-                        <a:t>91</a:t>
-                      </a:r>
-                    </a:p>
-                  </a:txBody>
-                  <a:tcPr>
-                    <a:solidFill>
-                      <a:srgbClr val="3987E5"/>
-                    </a:solidFill>
-                  </a:tcPr>
-                </a:tc>
-                <a:tc>
-                  <a:txBody>
-                    <a:bodyPr wrap="square"/>
-                    <a:lstStyle/>
-                    <a:p>
-                      <a:r>
-                        <a:rPr sz="1000" b="0">
-                          <a:solidFill>
-                            <a:srgbClr val="0B0B0B"/>
-                          </a:solidFill>
-                          <a:latin typeface="Calibri"/>
-                        </a:rPr>
-                        <a:t>1</a:t>
-                      </a:r>
-                    </a:p>
-                  </a:txBody>
-                  <a:tcPr>
-                    <a:solidFill>
-                      <a:srgbClr val="CDE2FB"/>
-                    </a:solidFill>
-                  </a:tcPr>
-                </a:tc>
-                <a:tc>
-                  <a:txBody>
-                    <a:bodyPr wrap="square"/>
-                    <a:lstStyle/>
-                    <a:p>
-                      <a:r>
-                        <a:rPr sz="1000" b="0">
-                          <a:solidFill>
-                            <a:srgbClr val="0B0B0B"/>
-                          </a:solidFill>
-                          <a:latin typeface="Calibri"/>
-                        </a:rPr>
-                        <a:t>63</a:t>
-                      </a:r>
-                    </a:p>
-                  </a:txBody>
-                  <a:tcPr>
-                    <a:solidFill>
-                      <a:srgbClr val="6DA7EC"/>
+                      <a:srgbClr val="256ABF"/>
                     </a:solidFill>
                   </a:tcPr>
                 </a:tc>
@@ -4823,13 +4824,13 @@
                           </a:solidFill>
                           <a:latin typeface="Calibri"/>
                         </a:rPr>
-                        <a:t>96</a:t>
-                      </a:r>
-                    </a:p>
-                  </a:txBody>
-                  <a:tcPr>
-                    <a:solidFill>
-                      <a:srgbClr val="3987E5"/>
+                        <a:t>104</a:t>
+                      </a:r>
+                    </a:p>
+                  </a:txBody>
+                  <a:tcPr>
+                    <a:solidFill>
+                      <a:srgbClr val="0D366B"/>
                     </a:solidFill>
                   </a:tcPr>
                 </a:tc>
@@ -4845,7 +4846,29 @@
                           </a:solidFill>
                           <a:latin typeface="Calibri"/>
                         </a:rPr>
-                        <a:t>101</a:t>
+                        <a:t>105</a:t>
+                      </a:r>
+                    </a:p>
+                  </a:txBody>
+                  <a:tcPr>
+                    <a:solidFill>
+                      <a:srgbClr val="0D366B"/>
+                    </a:solidFill>
+                  </a:tcPr>
+                </a:tc>
+                <a:tc>
+                  <a:txBody>
+                    <a:bodyPr wrap="square"/>
+                    <a:lstStyle/>
+                    <a:p>
+                      <a:r>
+                        <a:rPr sz="1000" b="0">
+                          <a:solidFill>
+                            <a:srgbClr val="FFFFFF"/>
+                          </a:solidFill>
+                          <a:latin typeface="Calibri"/>
+                        </a:rPr>
+                        <a:t>75</a:t>
                       </a:r>
                     </a:p>
                   </a:txBody>
@@ -4867,29 +4890,7 @@
                           </a:solidFill>
                           <a:latin typeface="Calibri"/>
                         </a:rPr>
-                        <a:t>3</a:t>
-                      </a:r>
-                    </a:p>
-                  </a:txBody>
-                  <a:tcPr>
-                    <a:solidFill>
-                      <a:srgbClr val="CDE2FB"/>
-                    </a:solidFill>
-                  </a:tcPr>
-                </a:tc>
-                <a:tc>
-                  <a:txBody>
-                    <a:bodyPr wrap="square"/>
-                    <a:lstStyle/>
-                    <a:p>
-                      <a:r>
-                        <a:rPr sz="1000" b="0">
-                          <a:solidFill>
-                            <a:srgbClr val="0B0B0B"/>
-                          </a:solidFill>
-                          <a:latin typeface="Calibri"/>
-                        </a:rPr>
-                        <a:t>27</a:t>
+                        <a:t>28</a:t>
                       </a:r>
                     </a:p>
                   </a:txBody>
@@ -4913,57 +4914,79 @@
                           </a:solidFill>
                           <a:latin typeface="Calibri"/>
                         </a:rPr>
-                        <a:t>Multimercado</a:t>
-                      </a:r>
-                    </a:p>
-                  </a:txBody>
-                  <a:tcPr>
-                    <a:solidFill>
-                      <a:srgbClr val="FFFFFF"/>
-                    </a:solidFill>
-                  </a:tcPr>
-                </a:tc>
-                <a:tc>
-                  <a:txBody>
-                    <a:bodyPr wrap="square"/>
-                    <a:lstStyle/>
-                    <a:p>
-                      <a:r>
-                        <a:rPr sz="1000" b="0">
-                          <a:solidFill>
-                            <a:srgbClr val="0B0B0B"/>
-                          </a:solidFill>
-                          <a:latin typeface="Calibri"/>
-                        </a:rPr>
-                        <a:t>9</a:t>
-                      </a:r>
-                    </a:p>
-                  </a:txBody>
-                  <a:tcPr>
-                    <a:solidFill>
-                      <a:srgbClr val="CDE2FB"/>
-                    </a:solidFill>
-                  </a:tcPr>
-                </a:tc>
-                <a:tc>
-                  <a:txBody>
-                    <a:bodyPr wrap="square"/>
-                    <a:lstStyle/>
-                    <a:p>
-                      <a:r>
-                        <a:rPr sz="1000" b="0">
-                          <a:solidFill>
-                            <a:srgbClr val="898781"/>
-                          </a:solidFill>
-                          <a:latin typeface="Calibri"/>
-                        </a:rPr>
-                        <a:t>-</a:t>
-                      </a:r>
-                    </a:p>
-                  </a:txBody>
-                  <a:tcPr>
-                    <a:solidFill>
-                      <a:srgbClr val="FFFFFF"/>
+                        <a:t>Multimercados Macro</a:t>
+                      </a:r>
+                    </a:p>
+                  </a:txBody>
+                  <a:tcPr>
+                    <a:solidFill>
+                      <a:srgbClr val="FFFFFF"/>
+                    </a:solidFill>
+                  </a:tcPr>
+                </a:tc>
+                <a:tc>
+                  <a:txBody>
+                    <a:bodyPr wrap="square"/>
+                    <a:lstStyle/>
+                    <a:p>
+                      <a:r>
+                        <a:rPr sz="1000" b="0">
+                          <a:solidFill>
+                            <a:srgbClr val="0B0B0B"/>
+                          </a:solidFill>
+                          <a:latin typeface="Calibri"/>
+                        </a:rPr>
+                        <a:t>44</a:t>
+                      </a:r>
+                    </a:p>
+                  </a:txBody>
+                  <a:tcPr>
+                    <a:solidFill>
+                      <a:srgbClr val="6DA7EC"/>
+                    </a:solidFill>
+                  </a:tcPr>
+                </a:tc>
+                <a:tc>
+                  <a:txBody>
+                    <a:bodyPr wrap="square"/>
+                    <a:lstStyle/>
+                    <a:p>
+                      <a:r>
+                        <a:rPr sz="1000" b="0">
+                          <a:solidFill>
+                            <a:srgbClr val="0B0B0B"/>
+                          </a:solidFill>
+                          <a:latin typeface="Calibri"/>
+                        </a:rPr>
+                        <a:t>35</a:t>
+                      </a:r>
+                    </a:p>
+                  </a:txBody>
+                  <a:tcPr>
+                    <a:solidFill>
+                      <a:srgbClr val="6DA7EC"/>
+                    </a:solidFill>
+                  </a:tcPr>
+                </a:tc>
+                <a:tc>
+                  <a:txBody>
+                    <a:bodyPr wrap="square"/>
+                    <a:lstStyle/>
+                    <a:p>
+                      <a:r>
+                        <a:rPr sz="1000" b="0">
+                          <a:solidFill>
+                            <a:srgbClr val="0B0B0B"/>
+                          </a:solidFill>
+                          <a:latin typeface="Calibri"/>
+                        </a:rPr>
+                        <a:t>39</a:t>
+                      </a:r>
+                    </a:p>
+                  </a:txBody>
+                  <a:tcPr>
+                    <a:solidFill>
+                      <a:srgbClr val="6DA7EC"/>
                     </a:solidFill>
                   </a:tcPr>
                 </a:tc>
@@ -4979,35 +5002,13 @@
                           </a:solidFill>
                           <a:latin typeface="Calibri"/>
                         </a:rPr>
-                        <a:t>169</a:t>
-                      </a:r>
-                    </a:p>
-                  </a:txBody>
-                  <a:tcPr>
-                    <a:solidFill>
-                      <a:srgbClr val="0D366B"/>
-                    </a:solidFill>
-                  </a:tcPr>
-                </a:tc>
-                <a:tc>
-                  <a:txBody>
-                    <a:bodyPr wrap="square"/>
-                    <a:lstStyle/>
-                    <a:p>
-                      <a:r>
-                        <a:rPr sz="1000" b="0">
-                          <a:solidFill>
-                            <a:srgbClr val="0B0B0B"/>
-                          </a:solidFill>
-                          <a:latin typeface="Calibri"/>
-                        </a:rPr>
-                        <a:t>49</a:t>
-                      </a:r>
-                    </a:p>
-                  </a:txBody>
-                  <a:tcPr>
-                    <a:solidFill>
-                      <a:srgbClr val="6DA7EC"/>
+                        <a:t>53</a:t>
+                      </a:r>
+                    </a:p>
+                  </a:txBody>
+                  <a:tcPr>
+                    <a:solidFill>
+                      <a:srgbClr val="3987E5"/>
                     </a:solidFill>
                   </a:tcPr>
                 </a:tc>
@@ -5025,95 +5026,95 @@
                           </a:solidFill>
                           <a:latin typeface="Calibri"/>
                         </a:rPr>
-                        <a:t>Acoes</a:t>
-                      </a:r>
-                    </a:p>
-                  </a:txBody>
-                  <a:tcPr>
-                    <a:solidFill>
-                      <a:srgbClr val="FFFFFF"/>
-                    </a:solidFill>
-                  </a:tcPr>
-                </a:tc>
-                <a:tc>
-                  <a:txBody>
-                    <a:bodyPr wrap="square"/>
-                    <a:lstStyle/>
-                    <a:p>
-                      <a:r>
-                        <a:rPr sz="1000" b="0">
-                          <a:solidFill>
-                            <a:srgbClr val="0B0B0B"/>
-                          </a:solidFill>
-                          <a:latin typeface="Calibri"/>
-                        </a:rPr>
-                        <a:t>12</a:t>
-                      </a:r>
-                    </a:p>
-                  </a:txBody>
-                  <a:tcPr>
-                    <a:solidFill>
-                      <a:srgbClr val="CDE2FB"/>
-                    </a:solidFill>
-                  </a:tcPr>
-                </a:tc>
-                <a:tc>
-                  <a:txBody>
-                    <a:bodyPr wrap="square"/>
-                    <a:lstStyle/>
-                    <a:p>
-                      <a:r>
-                        <a:rPr sz="1000" b="0">
-                          <a:solidFill>
-                            <a:srgbClr val="898781"/>
-                          </a:solidFill>
-                          <a:latin typeface="Calibri"/>
-                        </a:rPr>
-                        <a:t>-</a:t>
-                      </a:r>
-                    </a:p>
-                  </a:txBody>
-                  <a:tcPr>
-                    <a:solidFill>
-                      <a:srgbClr val="FFFFFF"/>
-                    </a:solidFill>
-                  </a:tcPr>
-                </a:tc>
-                <a:tc>
-                  <a:txBody>
-                    <a:bodyPr wrap="square"/>
-                    <a:lstStyle/>
-                    <a:p>
-                      <a:r>
-                        <a:rPr sz="1000" b="0">
-                          <a:solidFill>
-                            <a:srgbClr val="FFFFFF"/>
-                          </a:solidFill>
-                          <a:latin typeface="Calibri"/>
-                        </a:rPr>
-                        <a:t>101</a:t>
-                      </a:r>
-                    </a:p>
-                  </a:txBody>
-                  <a:tcPr>
-                    <a:solidFill>
-                      <a:srgbClr val="256ABF"/>
-                    </a:solidFill>
-                  </a:tcPr>
-                </a:tc>
-                <a:tc>
-                  <a:txBody>
-                    <a:bodyPr wrap="square"/>
-                    <a:lstStyle/>
-                    <a:p>
-                      <a:r>
-                        <a:rPr sz="1000" b="0">
-                          <a:solidFill>
-                            <a:srgbClr val="0B0B0B"/>
-                          </a:solidFill>
-                          <a:latin typeface="Calibri"/>
-                        </a:rPr>
-                        <a:t>30</a:t>
+                        <a:t>Multimercados Invest. no Exterior</a:t>
+                      </a:r>
+                    </a:p>
+                  </a:txBody>
+                  <a:tcPr>
+                    <a:solidFill>
+                      <a:srgbClr val="FFFFFF"/>
+                    </a:solidFill>
+                  </a:tcPr>
+                </a:tc>
+                <a:tc>
+                  <a:txBody>
+                    <a:bodyPr wrap="square"/>
+                    <a:lstStyle/>
+                    <a:p>
+                      <a:r>
+                        <a:rPr sz="1000" b="0">
+                          <a:solidFill>
+                            <a:srgbClr val="0B0B0B"/>
+                          </a:solidFill>
+                          <a:latin typeface="Calibri"/>
+                        </a:rPr>
+                        <a:t>31</a:t>
+                      </a:r>
+                    </a:p>
+                  </a:txBody>
+                  <a:tcPr>
+                    <a:solidFill>
+                      <a:srgbClr val="9EC5F4"/>
+                    </a:solidFill>
+                  </a:tcPr>
+                </a:tc>
+                <a:tc>
+                  <a:txBody>
+                    <a:bodyPr wrap="square"/>
+                    <a:lstStyle/>
+                    <a:p>
+                      <a:r>
+                        <a:rPr sz="1000" b="0">
+                          <a:solidFill>
+                            <a:srgbClr val="0B0B0B"/>
+                          </a:solidFill>
+                          <a:latin typeface="Calibri"/>
+                        </a:rPr>
+                        <a:t>45</a:t>
+                      </a:r>
+                    </a:p>
+                  </a:txBody>
+                  <a:tcPr>
+                    <a:solidFill>
+                      <a:srgbClr val="6DA7EC"/>
+                    </a:solidFill>
+                  </a:tcPr>
+                </a:tc>
+                <a:tc>
+                  <a:txBody>
+                    <a:bodyPr wrap="square"/>
+                    <a:lstStyle/>
+                    <a:p>
+                      <a:r>
+                        <a:rPr sz="1000" b="0">
+                          <a:solidFill>
+                            <a:srgbClr val="0B0B0B"/>
+                          </a:solidFill>
+                          <a:latin typeface="Calibri"/>
+                        </a:rPr>
+                        <a:t>33</a:t>
+                      </a:r>
+                    </a:p>
+                  </a:txBody>
+                  <a:tcPr>
+                    <a:solidFill>
+                      <a:srgbClr val="6DA7EC"/>
+                    </a:solidFill>
+                  </a:tcPr>
+                </a:tc>
+                <a:tc>
+                  <a:txBody>
+                    <a:bodyPr wrap="square"/>
+                    <a:lstStyle/>
+                    <a:p>
+                      <a:r>
+                        <a:rPr sz="1000" b="0">
+                          <a:solidFill>
+                            <a:srgbClr val="0B0B0B"/>
+                          </a:solidFill>
+                          <a:latin typeface="Calibri"/>
+                        </a:rPr>
+                        <a:t>22</a:t>
                       </a:r>
                     </a:p>
                   </a:txBody>
@@ -5137,101 +5138,101 @@
                           </a:solidFill>
                           <a:latin typeface="Calibri"/>
                         </a:rPr>
-                        <a:t>Renda Fixa</a:t>
-                      </a:r>
-                    </a:p>
-                  </a:txBody>
-                  <a:tcPr>
-                    <a:solidFill>
-                      <a:srgbClr val="FFFFFF"/>
-                    </a:solidFill>
-                  </a:tcPr>
-                </a:tc>
-                <a:tc>
-                  <a:txBody>
-                    <a:bodyPr wrap="square"/>
-                    <a:lstStyle/>
-                    <a:p>
-                      <a:r>
-                        <a:rPr sz="1000" b="0">
-                          <a:solidFill>
-                            <a:srgbClr val="0B0B0B"/>
-                          </a:solidFill>
-                          <a:latin typeface="Calibri"/>
-                        </a:rPr>
-                        <a:t>26</a:t>
+                        <a:t>Renda Fixa Duração Livre Grau de Invest.</a:t>
+                      </a:r>
+                    </a:p>
+                  </a:txBody>
+                  <a:tcPr>
+                    <a:solidFill>
+                      <a:srgbClr val="FFFFFF"/>
+                    </a:solidFill>
+                  </a:tcPr>
+                </a:tc>
+                <a:tc>
+                  <a:txBody>
+                    <a:bodyPr wrap="square"/>
+                    <a:lstStyle/>
+                    <a:p>
+                      <a:r>
+                        <a:rPr sz="1000" b="0">
+                          <a:solidFill>
+                            <a:srgbClr val="0B0B0B"/>
+                          </a:solidFill>
+                          <a:latin typeface="Calibri"/>
+                        </a:rPr>
+                        <a:t>40</a:t>
+                      </a:r>
+                    </a:p>
+                  </a:txBody>
+                  <a:tcPr>
+                    <a:solidFill>
+                      <a:srgbClr val="6DA7EC"/>
+                    </a:solidFill>
+                  </a:tcPr>
+                </a:tc>
+                <a:tc>
+                  <a:txBody>
+                    <a:bodyPr wrap="square"/>
+                    <a:lstStyle/>
+                    <a:p>
+                      <a:r>
+                        <a:rPr sz="1000" b="0">
+                          <a:solidFill>
+                            <a:srgbClr val="0B0B0B"/>
+                          </a:solidFill>
+                          <a:latin typeface="Calibri"/>
+                        </a:rPr>
+                        <a:t>40</a:t>
+                      </a:r>
+                    </a:p>
+                  </a:txBody>
+                  <a:tcPr>
+                    <a:solidFill>
+                      <a:srgbClr val="6DA7EC"/>
+                    </a:solidFill>
+                  </a:tcPr>
+                </a:tc>
+                <a:tc>
+                  <a:txBody>
+                    <a:bodyPr wrap="square"/>
+                    <a:lstStyle/>
+                    <a:p>
+                      <a:r>
+                        <a:rPr sz="1000" b="0">
+                          <a:solidFill>
+                            <a:srgbClr val="0B0B0B"/>
+                          </a:solidFill>
+                          <a:latin typeface="Calibri"/>
+                        </a:rPr>
+                        <a:t>14</a:t>
+                      </a:r>
+                    </a:p>
+                  </a:txBody>
+                  <a:tcPr>
+                    <a:solidFill>
+                      <a:srgbClr val="CDE2FB"/>
+                    </a:solidFill>
+                  </a:tcPr>
+                </a:tc>
+                <a:tc>
+                  <a:txBody>
+                    <a:bodyPr wrap="square"/>
+                    <a:lstStyle/>
+                    <a:p>
+                      <a:r>
+                        <a:rPr sz="1000" b="0">
+                          <a:solidFill>
+                            <a:srgbClr val="0B0B0B"/>
+                          </a:solidFill>
+                          <a:latin typeface="Calibri"/>
+                        </a:rPr>
+                        <a:t>24</a:t>
                       </a:r>
                     </a:p>
                   </a:txBody>
                   <a:tcPr>
                     <a:solidFill>
                       <a:srgbClr val="9EC5F4"/>
-                    </a:solidFill>
-                  </a:tcPr>
-                </a:tc>
-                <a:tc>
-                  <a:txBody>
-                    <a:bodyPr wrap="square"/>
-                    <a:lstStyle/>
-                    <a:p>
-                      <a:r>
-                        <a:rPr sz="1000" b="0">
-                          <a:solidFill>
-                            <a:srgbClr val="898781"/>
-                          </a:solidFill>
-                          <a:latin typeface="Calibri"/>
-                        </a:rPr>
-                        <a:t>-</a:t>
-                      </a:r>
-                    </a:p>
-                  </a:txBody>
-                  <a:tcPr>
-                    <a:solidFill>
-                      <a:srgbClr val="FFFFFF"/>
-                    </a:solidFill>
-                  </a:tcPr>
-                </a:tc>
-                <a:tc>
-                  <a:txBody>
-                    <a:bodyPr wrap="square"/>
-                    <a:lstStyle/>
-                    <a:p>
-                      <a:r>
-                        <a:rPr sz="1000" b="0">
-                          <a:solidFill>
-                            <a:srgbClr val="FFFFFF"/>
-                          </a:solidFill>
-                          <a:latin typeface="Calibri"/>
-                        </a:rPr>
-                        <a:t>115</a:t>
-                      </a:r>
-                    </a:p>
-                  </a:txBody>
-                  <a:tcPr>
-                    <a:solidFill>
-                      <a:srgbClr val="256ABF"/>
-                    </a:solidFill>
-                  </a:tcPr>
-                </a:tc>
-                <a:tc>
-                  <a:txBody>
-                    <a:bodyPr wrap="square"/>
-                    <a:lstStyle/>
-                    <a:p>
-                      <a:r>
-                        <a:rPr sz="1000" b="0">
-                          <a:solidFill>
-                            <a:srgbClr val="898781"/>
-                          </a:solidFill>
-                          <a:latin typeface="Calibri"/>
-                        </a:rPr>
-                        <a:t>-</a:t>
-                      </a:r>
-                    </a:p>
-                  </a:txBody>
-                  <a:tcPr>
-                    <a:solidFill>
-                      <a:srgbClr val="FFFFFF"/>
                     </a:solidFill>
                   </a:tcPr>
                 </a:tc>
@@ -5249,29 +5250,73 @@
                           </a:solidFill>
                           <a:latin typeface="Calibri"/>
                         </a:rPr>
-                        <a:t>Multimercados Macro</a:t>
-                      </a:r>
-                    </a:p>
-                  </a:txBody>
-                  <a:tcPr>
-                    <a:solidFill>
-                      <a:srgbClr val="FFFFFF"/>
-                    </a:solidFill>
-                  </a:tcPr>
-                </a:tc>
-                <a:tc>
-                  <a:txBody>
-                    <a:bodyPr wrap="square"/>
-                    <a:lstStyle/>
-                    <a:p>
-                      <a:r>
-                        <a:rPr sz="1000" b="0">
-                          <a:solidFill>
-                            <a:srgbClr val="0B0B0B"/>
-                          </a:solidFill>
-                          <a:latin typeface="Calibri"/>
-                        </a:rPr>
-                        <a:t>40</a:t>
+                        <a:t>Ações Invest. no Exterior</a:t>
+                      </a:r>
+                    </a:p>
+                  </a:txBody>
+                  <a:tcPr>
+                    <a:solidFill>
+                      <a:srgbClr val="FFFFFF"/>
+                    </a:solidFill>
+                  </a:tcPr>
+                </a:tc>
+                <a:tc>
+                  <a:txBody>
+                    <a:bodyPr wrap="square"/>
+                    <a:lstStyle/>
+                    <a:p>
+                      <a:r>
+                        <a:rPr sz="1000" b="0">
+                          <a:solidFill>
+                            <a:srgbClr val="0B0B0B"/>
+                          </a:solidFill>
+                          <a:latin typeface="Calibri"/>
+                        </a:rPr>
+                        <a:t>38</a:t>
+                      </a:r>
+                    </a:p>
+                  </a:txBody>
+                  <a:tcPr>
+                    <a:solidFill>
+                      <a:srgbClr val="6DA7EC"/>
+                    </a:solidFill>
+                  </a:tcPr>
+                </a:tc>
+                <a:tc>
+                  <a:txBody>
+                    <a:bodyPr wrap="square"/>
+                    <a:lstStyle/>
+                    <a:p>
+                      <a:r>
+                        <a:rPr sz="1000" b="0">
+                          <a:solidFill>
+                            <a:srgbClr val="0B0B0B"/>
+                          </a:solidFill>
+                          <a:latin typeface="Calibri"/>
+                        </a:rPr>
+                        <a:t>38</a:t>
+                      </a:r>
+                    </a:p>
+                  </a:txBody>
+                  <a:tcPr>
+                    <a:solidFill>
+                      <a:srgbClr val="6DA7EC"/>
+                    </a:solidFill>
+                  </a:tcPr>
+                </a:tc>
+                <a:tc>
+                  <a:txBody>
+                    <a:bodyPr wrap="square"/>
+                    <a:lstStyle/>
+                    <a:p>
+                      <a:r>
+                        <a:rPr sz="1000" b="0">
+                          <a:solidFill>
+                            <a:srgbClr val="0B0B0B"/>
+                          </a:solidFill>
+                          <a:latin typeface="Calibri"/>
+                        </a:rPr>
+                        <a:t>24</a:t>
                       </a:r>
                     </a:p>
                   </a:txBody>
@@ -5293,51 +5338,7 @@
                           </a:solidFill>
                           <a:latin typeface="Calibri"/>
                         </a:rPr>
-                        <a:t>35</a:t>
-                      </a:r>
-                    </a:p>
-                  </a:txBody>
-                  <a:tcPr>
-                    <a:solidFill>
-                      <a:srgbClr val="9EC5F4"/>
-                    </a:solidFill>
-                  </a:tcPr>
-                </a:tc>
-                <a:tc>
-                  <a:txBody>
-                    <a:bodyPr wrap="square"/>
-                    <a:lstStyle/>
-                    <a:p>
-                      <a:r>
-                        <a:rPr sz="1000" b="0">
-                          <a:solidFill>
-                            <a:srgbClr val="0B0B0B"/>
-                          </a:solidFill>
-                          <a:latin typeface="Calibri"/>
-                        </a:rPr>
-                        <a:t>1</a:t>
-                      </a:r>
-                    </a:p>
-                  </a:txBody>
-                  <a:tcPr>
-                    <a:solidFill>
-                      <a:srgbClr val="CDE2FB"/>
-                    </a:solidFill>
-                  </a:tcPr>
-                </a:tc>
-                <a:tc>
-                  <a:txBody>
-                    <a:bodyPr wrap="square"/>
-                    <a:lstStyle/>
-                    <a:p>
-                      <a:r>
-                        <a:rPr sz="1000" b="0">
-                          <a:solidFill>
-                            <a:srgbClr val="0B0B0B"/>
-                          </a:solidFill>
-                          <a:latin typeface="Calibri"/>
-                        </a:rPr>
-                        <a:t>42</a:t>
+                        <a:t>17</a:t>
                       </a:r>
                     </a:p>
                   </a:txBody>
@@ -5361,7 +5362,7 @@
                           </a:solidFill>
                           <a:latin typeface="Calibri"/>
                         </a:rPr>
-                        <a:t>Renda Fixa Duração Livre Grau de Invest.</a:t>
+                        <a:t>Renda Fixa Duração Baixa Grau de Invest.</a:t>
                       </a:r>
                     </a:p>
                   </a:txBody>
@@ -5389,73 +5390,73 @@
                   </a:txBody>
                   <a:tcPr>
                     <a:solidFill>
+                      <a:srgbClr val="6DA7EC"/>
+                    </a:solidFill>
+                  </a:tcPr>
+                </a:tc>
+                <a:tc>
+                  <a:txBody>
+                    <a:bodyPr wrap="square"/>
+                    <a:lstStyle/>
+                    <a:p>
+                      <a:r>
+                        <a:rPr sz="1000" b="0">
+                          <a:solidFill>
+                            <a:srgbClr val="0B0B0B"/>
+                          </a:solidFill>
+                          <a:latin typeface="Calibri"/>
+                        </a:rPr>
+                        <a:t>34</a:t>
+                      </a:r>
+                    </a:p>
+                  </a:txBody>
+                  <a:tcPr>
+                    <a:solidFill>
+                      <a:srgbClr val="6DA7EC"/>
+                    </a:solidFill>
+                  </a:tcPr>
+                </a:tc>
+                <a:tc>
+                  <a:txBody>
+                    <a:bodyPr wrap="square"/>
+                    <a:lstStyle/>
+                    <a:p>
+                      <a:r>
+                        <a:rPr sz="1000" b="0">
+                          <a:solidFill>
+                            <a:srgbClr val="0B0B0B"/>
+                          </a:solidFill>
+                          <a:latin typeface="Calibri"/>
+                        </a:rPr>
+                        <a:t>8</a:t>
+                      </a:r>
+                    </a:p>
+                  </a:txBody>
+                  <a:tcPr>
+                    <a:solidFill>
+                      <a:srgbClr val="CDE2FB"/>
+                    </a:solidFill>
+                  </a:tcPr>
+                </a:tc>
+                <a:tc>
+                  <a:txBody>
+                    <a:bodyPr wrap="square"/>
+                    <a:lstStyle/>
+                    <a:p>
+                      <a:r>
+                        <a:rPr sz="1000" b="0">
+                          <a:solidFill>
+                            <a:srgbClr val="0B0B0B"/>
+                          </a:solidFill>
+                          <a:latin typeface="Calibri"/>
+                        </a:rPr>
+                        <a:t>20</a:t>
+                      </a:r>
+                    </a:p>
+                  </a:txBody>
+                  <a:tcPr>
+                    <a:solidFill>
                       <a:srgbClr val="9EC5F4"/>
-                    </a:solidFill>
-                  </a:tcPr>
-                </a:tc>
-                <a:tc>
-                  <a:txBody>
-                    <a:bodyPr wrap="square"/>
-                    <a:lstStyle/>
-                    <a:p>
-                      <a:r>
-                        <a:rPr sz="1000" b="0">
-                          <a:solidFill>
-                            <a:srgbClr val="0B0B0B"/>
-                          </a:solidFill>
-                          <a:latin typeface="Calibri"/>
-                        </a:rPr>
-                        <a:t>40</a:t>
-                      </a:r>
-                    </a:p>
-                  </a:txBody>
-                  <a:tcPr>
-                    <a:solidFill>
-                      <a:srgbClr val="9EC5F4"/>
-                    </a:solidFill>
-                  </a:tcPr>
-                </a:tc>
-                <a:tc>
-                  <a:txBody>
-                    <a:bodyPr wrap="square"/>
-                    <a:lstStyle/>
-                    <a:p>
-                      <a:r>
-                        <a:rPr sz="1000" b="0">
-                          <a:solidFill>
-                            <a:srgbClr val="898781"/>
-                          </a:solidFill>
-                          <a:latin typeface="Calibri"/>
-                        </a:rPr>
-                        <a:t>-</a:t>
-                      </a:r>
-                    </a:p>
-                  </a:txBody>
-                  <a:tcPr>
-                    <a:solidFill>
-                      <a:srgbClr val="FFFFFF"/>
-                    </a:solidFill>
-                  </a:tcPr>
-                </a:tc>
-                <a:tc>
-                  <a:txBody>
-                    <a:bodyPr wrap="square"/>
-                    <a:lstStyle/>
-                    <a:p>
-                      <a:r>
-                        <a:rPr sz="1000" b="0">
-                          <a:solidFill>
-                            <a:srgbClr val="0B0B0B"/>
-                          </a:solidFill>
-                          <a:latin typeface="Calibri"/>
-                        </a:rPr>
-                        <a:t>23</a:t>
-                      </a:r>
-                    </a:p>
-                  </a:txBody>
-                  <a:tcPr>
-                    <a:solidFill>
-                      <a:srgbClr val="CDE2FB"/>
                     </a:solidFill>
                   </a:tcPr>
                 </a:tc>
@@ -5473,29 +5474,29 @@
                           </a:solidFill>
                           <a:latin typeface="Calibri"/>
                         </a:rPr>
-                        <a:t>Ações Invest. no Exterior</a:t>
-                      </a:r>
-                    </a:p>
-                  </a:txBody>
-                  <a:tcPr>
-                    <a:solidFill>
-                      <a:srgbClr val="FFFFFF"/>
-                    </a:solidFill>
-                  </a:tcPr>
-                </a:tc>
-                <a:tc>
-                  <a:txBody>
-                    <a:bodyPr wrap="square"/>
-                    <a:lstStyle/>
-                    <a:p>
-                      <a:r>
-                        <a:rPr sz="1000" b="0">
-                          <a:solidFill>
-                            <a:srgbClr val="0B0B0B"/>
-                          </a:solidFill>
-                          <a:latin typeface="Calibri"/>
-                        </a:rPr>
-                        <a:t>38</a:t>
+                        <a:t>Multimercados Estrat. Específica</a:t>
+                      </a:r>
+                    </a:p>
+                  </a:txBody>
+                  <a:tcPr>
+                    <a:solidFill>
+                      <a:srgbClr val="FFFFFF"/>
+                    </a:solidFill>
+                  </a:tcPr>
+                </a:tc>
+                <a:tc>
+                  <a:txBody>
+                    <a:bodyPr wrap="square"/>
+                    <a:lstStyle/>
+                    <a:p>
+                      <a:r>
+                        <a:rPr sz="1000" b="0">
+                          <a:solidFill>
+                            <a:srgbClr val="0B0B0B"/>
+                          </a:solidFill>
+                          <a:latin typeface="Calibri"/>
+                        </a:rPr>
+                        <a:t>27</a:t>
                       </a:r>
                     </a:p>
                   </a:txBody>
@@ -5517,7 +5518,7 @@
                           </a:solidFill>
                           <a:latin typeface="Calibri"/>
                         </a:rPr>
-                        <a:t>38</a:t>
+                        <a:t>25</a:t>
                       </a:r>
                     </a:p>
                   </a:txBody>
@@ -5539,7 +5540,7 @@
                           </a:solidFill>
                           <a:latin typeface="Calibri"/>
                         </a:rPr>
-                        <a:t>1</a:t>
+                        <a:t>12</a:t>
                       </a:r>
                     </a:p>
                   </a:txBody>
@@ -5561,13 +5562,13 @@
                           </a:solidFill>
                           <a:latin typeface="Calibri"/>
                         </a:rPr>
-                        <a:t>13</a:t>
-                      </a:r>
-                    </a:p>
-                  </a:txBody>
-                  <a:tcPr>
-                    <a:solidFill>
-                      <a:srgbClr val="CDE2FB"/>
+                        <a:t>17</a:t>
+                      </a:r>
+                    </a:p>
+                  </a:txBody>
+                  <a:tcPr>
+                    <a:solidFill>
+                      <a:srgbClr val="9EC5F4"/>
                     </a:solidFill>
                   </a:tcPr>
                 </a:tc>
@@ -5585,73 +5586,51 @@
                           </a:solidFill>
                           <a:latin typeface="Calibri"/>
                         </a:rPr>
-                        <a:t>Renda Fixa Duração Baixa Grau de Invest.</a:t>
-                      </a:r>
-                    </a:p>
-                  </a:txBody>
-                  <a:tcPr>
-                    <a:solidFill>
-                      <a:srgbClr val="FFFFFF"/>
-                    </a:solidFill>
-                  </a:tcPr>
-                </a:tc>
-                <a:tc>
-                  <a:txBody>
-                    <a:bodyPr wrap="square"/>
-                    <a:lstStyle/>
-                    <a:p>
-                      <a:r>
-                        <a:rPr sz="1000" b="0">
-                          <a:solidFill>
-                            <a:srgbClr val="0B0B0B"/>
-                          </a:solidFill>
-                          <a:latin typeface="Calibri"/>
-                        </a:rPr>
-                        <a:t>30</a:t>
-                      </a:r>
-                    </a:p>
-                  </a:txBody>
-                  <a:tcPr>
-                    <a:solidFill>
-                      <a:srgbClr val="9EC5F4"/>
-                    </a:solidFill>
-                  </a:tcPr>
-                </a:tc>
-                <a:tc>
-                  <a:txBody>
-                    <a:bodyPr wrap="square"/>
-                    <a:lstStyle/>
-                    <a:p>
-                      <a:r>
-                        <a:rPr sz="1000" b="0">
-                          <a:solidFill>
-                            <a:srgbClr val="0B0B0B"/>
-                          </a:solidFill>
-                          <a:latin typeface="Calibri"/>
-                        </a:rPr>
-                        <a:t>34</a:t>
-                      </a:r>
-                    </a:p>
-                  </a:txBody>
-                  <a:tcPr>
-                    <a:solidFill>
-                      <a:srgbClr val="9EC5F4"/>
-                    </a:solidFill>
-                  </a:tcPr>
-                </a:tc>
-                <a:tc>
-                  <a:txBody>
-                    <a:bodyPr wrap="square"/>
-                    <a:lstStyle/>
-                    <a:p>
-                      <a:r>
-                        <a:rPr sz="1000" b="0">
-                          <a:solidFill>
-                            <a:srgbClr val="0B0B0B"/>
-                          </a:solidFill>
-                          <a:latin typeface="Calibri"/>
-                        </a:rPr>
-                        <a:t>1</a:t>
+                        <a:t>Estruturado (sem classificacao ANBIMA)</a:t>
+                      </a:r>
+                    </a:p>
+                  </a:txBody>
+                  <a:tcPr>
+                    <a:solidFill>
+                      <a:srgbClr val="FFFFFF"/>
+                    </a:solidFill>
+                  </a:tcPr>
+                </a:tc>
+                <a:tc>
+                  <a:txBody>
+                    <a:bodyPr wrap="square"/>
+                    <a:lstStyle/>
+                    <a:p>
+                      <a:r>
+                        <a:rPr sz="1000" b="0">
+                          <a:solidFill>
+                            <a:srgbClr val="0B0B0B"/>
+                          </a:solidFill>
+                          <a:latin typeface="Calibri"/>
+                        </a:rPr>
+                        <a:t>43</a:t>
+                      </a:r>
+                    </a:p>
+                  </a:txBody>
+                  <a:tcPr>
+                    <a:solidFill>
+                      <a:srgbClr val="6DA7EC"/>
+                    </a:solidFill>
+                  </a:tcPr>
+                </a:tc>
+                <a:tc>
+                  <a:txBody>
+                    <a:bodyPr wrap="square"/>
+                    <a:lstStyle/>
+                    <a:p>
+                      <a:r>
+                        <a:rPr sz="1000" b="0">
+                          <a:solidFill>
+                            <a:srgbClr val="0B0B0B"/>
+                          </a:solidFill>
+                          <a:latin typeface="Calibri"/>
+                        </a:rPr>
+                        <a:t>3</a:t>
                       </a:r>
                     </a:p>
                   </a:txBody>
@@ -5673,7 +5652,29 @@
                           </a:solidFill>
                           <a:latin typeface="Calibri"/>
                         </a:rPr>
-                        <a:t>19</a:t>
+                        <a:t>4</a:t>
+                      </a:r>
+                    </a:p>
+                  </a:txBody>
+                  <a:tcPr>
+                    <a:solidFill>
+                      <a:srgbClr val="CDE2FB"/>
+                    </a:solidFill>
+                  </a:tcPr>
+                </a:tc>
+                <a:tc>
+                  <a:txBody>
+                    <a:bodyPr wrap="square"/>
+                    <a:lstStyle/>
+                    <a:p>
+                      <a:r>
+                        <a:rPr sz="1000" b="0">
+                          <a:solidFill>
+                            <a:srgbClr val="0B0B0B"/>
+                          </a:solidFill>
+                          <a:latin typeface="Calibri"/>
+                        </a:rPr>
+                        <a:t>2</a:t>
                       </a:r>
                     </a:p>
                   </a:txBody>
@@ -5697,29 +5698,29 @@
                           </a:solidFill>
                           <a:latin typeface="Calibri"/>
                         </a:rPr>
-                        <a:t>Multimercados Invest. no Exterior</a:t>
-                      </a:r>
-                    </a:p>
-                  </a:txBody>
-                  <a:tcPr>
-                    <a:solidFill>
-                      <a:srgbClr val="FFFFFF"/>
-                    </a:solidFill>
-                  </a:tcPr>
-                </a:tc>
-                <a:tc>
-                  <a:txBody>
-                    <a:bodyPr wrap="square"/>
-                    <a:lstStyle/>
-                    <a:p>
-                      <a:r>
-                        <a:rPr sz="1000" b="0">
-                          <a:solidFill>
-                            <a:srgbClr val="0B0B0B"/>
-                          </a:solidFill>
-                          <a:latin typeface="Calibri"/>
-                        </a:rPr>
-                        <a:t>30</a:t>
+                        <a:t>Multimercados L/S - Direcional</a:t>
+                      </a:r>
+                    </a:p>
+                  </a:txBody>
+                  <a:tcPr>
+                    <a:solidFill>
+                      <a:srgbClr val="FFFFFF"/>
+                    </a:solidFill>
+                  </a:tcPr>
+                </a:tc>
+                <a:tc>
+                  <a:txBody>
+                    <a:bodyPr wrap="square"/>
+                    <a:lstStyle/>
+                    <a:p>
+                      <a:r>
+                        <a:rPr sz="1000" b="0">
+                          <a:solidFill>
+                            <a:srgbClr val="0B0B0B"/>
+                          </a:solidFill>
+                          <a:latin typeface="Calibri"/>
+                        </a:rPr>
+                        <a:t>18</a:t>
                       </a:r>
                     </a:p>
                   </a:txBody>
@@ -5741,29 +5742,7 @@
                           </a:solidFill>
                           <a:latin typeface="Calibri"/>
                         </a:rPr>
-                        <a:t>41</a:t>
-                      </a:r>
-                    </a:p>
-                  </a:txBody>
-                  <a:tcPr>
-                    <a:solidFill>
-                      <a:srgbClr val="9EC5F4"/>
-                    </a:solidFill>
-                  </a:tcPr>
-                </a:tc>
-                <a:tc>
-                  <a:txBody>
-                    <a:bodyPr wrap="square"/>
-                    <a:lstStyle/>
-                    <a:p>
-                      <a:r>
-                        <a:rPr sz="1000" b="0">
-                          <a:solidFill>
-                            <a:srgbClr val="0B0B0B"/>
-                          </a:solidFill>
-                          <a:latin typeface="Calibri"/>
-                        </a:rPr>
-                        <a:t>1</a:t>
+                        <a:t>13</a:t>
                       </a:r>
                     </a:p>
                   </a:txBody>
@@ -5785,7 +5764,29 @@
                           </a:solidFill>
                           <a:latin typeface="Calibri"/>
                         </a:rPr>
-                        <a:t>11</a:t>
+                        <a:t>9</a:t>
+                      </a:r>
+                    </a:p>
+                  </a:txBody>
+                  <a:tcPr>
+                    <a:solidFill>
+                      <a:srgbClr val="CDE2FB"/>
+                    </a:solidFill>
+                  </a:tcPr>
+                </a:tc>
+                <a:tc>
+                  <a:txBody>
+                    <a:bodyPr wrap="square"/>
+                    <a:lstStyle/>
+                    <a:p>
+                      <a:r>
+                        <a:rPr sz="1000" b="0">
+                          <a:solidFill>
+                            <a:srgbClr val="0B0B0B"/>
+                          </a:solidFill>
+                          <a:latin typeface="Calibri"/>
+                        </a:rPr>
+                        <a:t>10</a:t>
                       </a:r>
                     </a:p>
                   </a:txBody>
@@ -5809,95 +5810,95 @@
                           </a:solidFill>
                           <a:latin typeface="Calibri"/>
                         </a:rPr>
-                        <a:t>Sem classificacao</a:t>
-                      </a:r>
-                    </a:p>
-                  </a:txBody>
-                  <a:tcPr>
-                    <a:solidFill>
-                      <a:srgbClr val="FFFFFF"/>
-                    </a:solidFill>
-                  </a:tcPr>
-                </a:tc>
-                <a:tc>
-                  <a:txBody>
-                    <a:bodyPr wrap="square"/>
-                    <a:lstStyle/>
-                    <a:p>
-                      <a:r>
-                        <a:rPr sz="1000" b="0">
-                          <a:solidFill>
-                            <a:srgbClr val="0B0B0B"/>
-                          </a:solidFill>
-                          <a:latin typeface="Calibri"/>
-                        </a:rPr>
-                        <a:t>45</a:t>
-                      </a:r>
-                    </a:p>
-                  </a:txBody>
-                  <a:tcPr>
-                    <a:solidFill>
-                      <a:srgbClr val="9EC5F4"/>
-                    </a:solidFill>
-                  </a:tcPr>
-                </a:tc>
-                <a:tc>
-                  <a:txBody>
-                    <a:bodyPr wrap="square"/>
-                    <a:lstStyle/>
-                    <a:p>
-                      <a:r>
-                        <a:rPr sz="1000" b="0">
-                          <a:solidFill>
-                            <a:srgbClr val="898781"/>
-                          </a:solidFill>
-                          <a:latin typeface="Calibri"/>
-                        </a:rPr>
-                        <a:t>-</a:t>
-                      </a:r>
-                    </a:p>
-                  </a:txBody>
-                  <a:tcPr>
-                    <a:solidFill>
-                      <a:srgbClr val="FFFFFF"/>
-                    </a:solidFill>
-                  </a:tcPr>
-                </a:tc>
-                <a:tc>
-                  <a:txBody>
-                    <a:bodyPr wrap="square"/>
-                    <a:lstStyle/>
-                    <a:p>
-                      <a:r>
-                        <a:rPr sz="1000" b="0">
-                          <a:solidFill>
-                            <a:srgbClr val="0B0B0B"/>
-                          </a:solidFill>
-                          <a:latin typeface="Calibri"/>
-                        </a:rPr>
-                        <a:t>26</a:t>
-                      </a:r>
-                    </a:p>
-                  </a:txBody>
-                  <a:tcPr>
-                    <a:solidFill>
-                      <a:srgbClr val="9EC5F4"/>
-                    </a:solidFill>
-                  </a:tcPr>
-                </a:tc>
-                <a:tc>
-                  <a:txBody>
-                    <a:bodyPr wrap="square"/>
-                    <a:lstStyle/>
-                    <a:p>
-                      <a:r>
-                        <a:rPr sz="1000" b="0">
-                          <a:solidFill>
-                            <a:srgbClr val="0B0B0B"/>
-                          </a:solidFill>
-                          <a:latin typeface="Calibri"/>
-                        </a:rPr>
-                        <a:t>11</a:t>
+                        <a:t>Multimercados Dinâmico</a:t>
+                      </a:r>
+                    </a:p>
+                  </a:txBody>
+                  <a:tcPr>
+                    <a:solidFill>
+                      <a:srgbClr val="FFFFFF"/>
+                    </a:solidFill>
+                  </a:tcPr>
+                </a:tc>
+                <a:tc>
+                  <a:txBody>
+                    <a:bodyPr wrap="square"/>
+                    <a:lstStyle/>
+                    <a:p>
+                      <a:r>
+                        <a:rPr sz="1000" b="0">
+                          <a:solidFill>
+                            <a:srgbClr val="0B0B0B"/>
+                          </a:solidFill>
+                          <a:latin typeface="Calibri"/>
+                        </a:rPr>
+                        <a:t>13</a:t>
+                      </a:r>
+                    </a:p>
+                  </a:txBody>
+                  <a:tcPr>
+                    <a:solidFill>
+                      <a:srgbClr val="CDE2FB"/>
+                    </a:solidFill>
+                  </a:tcPr>
+                </a:tc>
+                <a:tc>
+                  <a:txBody>
+                    <a:bodyPr wrap="square"/>
+                    <a:lstStyle/>
+                    <a:p>
+                      <a:r>
+                        <a:rPr sz="1000" b="0">
+                          <a:solidFill>
+                            <a:srgbClr val="0B0B0B"/>
+                          </a:solidFill>
+                          <a:latin typeface="Calibri"/>
+                        </a:rPr>
+                        <a:t>8</a:t>
+                      </a:r>
+                    </a:p>
+                  </a:txBody>
+                  <a:tcPr>
+                    <a:solidFill>
+                      <a:srgbClr val="CDE2FB"/>
+                    </a:solidFill>
+                  </a:tcPr>
+                </a:tc>
+                <a:tc>
+                  <a:txBody>
+                    <a:bodyPr wrap="square"/>
+                    <a:lstStyle/>
+                    <a:p>
+                      <a:r>
+                        <a:rPr sz="1000" b="0">
+                          <a:solidFill>
+                            <a:srgbClr val="0B0B0B"/>
+                          </a:solidFill>
+                          <a:latin typeface="Calibri"/>
+                        </a:rPr>
+                        <a:t>4</a:t>
+                      </a:r>
+                    </a:p>
+                  </a:txBody>
+                  <a:tcPr>
+                    <a:solidFill>
+                      <a:srgbClr val="CDE2FB"/>
+                    </a:solidFill>
+                  </a:tcPr>
+                </a:tc>
+                <a:tc>
+                  <a:txBody>
+                    <a:bodyPr wrap="square"/>
+                    <a:lstStyle/>
+                    <a:p>
+                      <a:r>
+                        <a:rPr sz="1000" b="0">
+                          <a:solidFill>
+                            <a:srgbClr val="0B0B0B"/>
+                          </a:solidFill>
+                          <a:latin typeface="Calibri"/>
+                        </a:rPr>
+                        <a:t>7</a:t>
                       </a:r>
                     </a:p>
                   </a:txBody>
@@ -7140,7 +7141,7 @@
                           </a:solidFill>
                           <a:latin typeface="Calibri"/>
                         </a:rPr>
-                        <a:t>Direitos Creditórios</a:t>
+                        <a:t>Renda Fixa Duração Livre Crédito Livre</a:t>
                       </a:r>
                     </a:p>
                   </a:txBody>
@@ -7740,51 +7741,51 @@
                           </a:solidFill>
                           <a:latin typeface="Calibri"/>
                         </a:rPr>
-                        <a:t>84</a:t>
-                      </a:r>
-                    </a:p>
-                  </a:txBody>
-                  <a:tcPr>
-                    <a:solidFill>
-                      <a:srgbClr val="FFFFFF"/>
-                    </a:solidFill>
-                  </a:tcPr>
-                </a:tc>
-                <a:tc>
-                  <a:txBody>
-                    <a:bodyPr wrap="square"/>
-                    <a:lstStyle/>
-                    <a:p>
-                      <a:r>
-                        <a:rPr sz="1000" b="0">
-                          <a:solidFill>
-                            <a:srgbClr val="0B0B0B"/>
-                          </a:solidFill>
-                          <a:latin typeface="Calibri"/>
-                        </a:rPr>
-                        <a:t>BTG Pactual (109)</a:t>
-                      </a:r>
-                    </a:p>
-                  </a:txBody>
-                  <a:tcPr>
-                    <a:solidFill>
-                      <a:srgbClr val="FFFFFF"/>
-                    </a:solidFill>
-                  </a:tcPr>
-                </a:tc>
-                <a:tc>
-                  <a:txBody>
-                    <a:bodyPr wrap="square"/>
-                    <a:lstStyle/>
-                    <a:p>
-                      <a:r>
-                        <a:rPr sz="1000" b="0">
-                          <a:solidFill>
-                            <a:srgbClr val="0B0B0B"/>
-                          </a:solidFill>
-                          <a:latin typeface="Calibri"/>
-                        </a:rPr>
-                        <a:t>102</a:t>
+                        <a:t>93</a:t>
+                      </a:r>
+                    </a:p>
+                  </a:txBody>
+                  <a:tcPr>
+                    <a:solidFill>
+                      <a:srgbClr val="FFFFFF"/>
+                    </a:solidFill>
+                  </a:tcPr>
+                </a:tc>
+                <a:tc>
+                  <a:txBody>
+                    <a:bodyPr wrap="square"/>
+                    <a:lstStyle/>
+                    <a:p>
+                      <a:r>
+                        <a:rPr sz="1000" b="0">
+                          <a:solidFill>
+                            <a:srgbClr val="0B0B0B"/>
+                          </a:solidFill>
+                          <a:latin typeface="Calibri"/>
+                        </a:rPr>
+                        <a:t>BTG Pactual (114)</a:t>
+                      </a:r>
+                    </a:p>
+                  </a:txBody>
+                  <a:tcPr>
+                    <a:solidFill>
+                      <a:srgbClr val="FFFFFF"/>
+                    </a:solidFill>
+                  </a:tcPr>
+                </a:tc>
+                <a:tc>
+                  <a:txBody>
+                    <a:bodyPr wrap="square"/>
+                    <a:lstStyle/>
+                    <a:p>
+                      <a:r>
+                        <a:rPr sz="1000" b="0">
+                          <a:solidFill>
+                            <a:srgbClr val="0B0B0B"/>
+                          </a:solidFill>
+                          <a:latin typeface="Calibri"/>
+                        </a:rPr>
+                        <a:t>120</a:t>
                       </a:r>
                     </a:p>
                   </a:txBody>
@@ -7830,51 +7831,51 @@
                           </a:solidFill>
                           <a:latin typeface="Calibri"/>
                         </a:rPr>
-                        <a:t>76</a:t>
-                      </a:r>
-                    </a:p>
-                  </a:txBody>
-                  <a:tcPr>
-                    <a:solidFill>
-                      <a:srgbClr val="FFFFFF"/>
-                    </a:solidFill>
-                  </a:tcPr>
-                </a:tc>
-                <a:tc>
-                  <a:txBody>
-                    <a:bodyPr wrap="square"/>
-                    <a:lstStyle/>
-                    <a:p>
-                      <a:r>
-                        <a:rPr sz="1000" b="0">
-                          <a:solidFill>
-                            <a:srgbClr val="0B0B0B"/>
-                          </a:solidFill>
-                          <a:latin typeface="Calibri"/>
-                        </a:rPr>
-                        <a:t>BTG Pactual (91)</a:t>
-                      </a:r>
-                    </a:p>
-                  </a:txBody>
-                  <a:tcPr>
-                    <a:solidFill>
-                      <a:srgbClr val="FFFFFF"/>
-                    </a:solidFill>
-                  </a:tcPr>
-                </a:tc>
-                <a:tc>
-                  <a:txBody>
-                    <a:bodyPr wrap="square"/>
-                    <a:lstStyle/>
-                    <a:p>
-                      <a:r>
-                        <a:rPr sz="1000" b="0">
-                          <a:solidFill>
-                            <a:srgbClr val="0B0B0B"/>
-                          </a:solidFill>
-                          <a:latin typeface="Calibri"/>
-                        </a:rPr>
-                        <a:t>95</a:t>
+                        <a:t>78</a:t>
+                      </a:r>
+                    </a:p>
+                  </a:txBody>
+                  <a:tcPr>
+                    <a:solidFill>
+                      <a:srgbClr val="FFFFFF"/>
+                    </a:solidFill>
+                  </a:tcPr>
+                </a:tc>
+                <a:tc>
+                  <a:txBody>
+                    <a:bodyPr wrap="square"/>
+                    <a:lstStyle/>
+                    <a:p>
+                      <a:r>
+                        <a:rPr sz="1000" b="0">
+                          <a:solidFill>
+                            <a:srgbClr val="0B0B0B"/>
+                          </a:solidFill>
+                          <a:latin typeface="Calibri"/>
+                        </a:rPr>
+                        <a:t>BTG Pactual (99)</a:t>
+                      </a:r>
+                    </a:p>
+                  </a:txBody>
+                  <a:tcPr>
+                    <a:solidFill>
+                      <a:srgbClr val="FFFFFF"/>
+                    </a:solidFill>
+                  </a:tcPr>
+                </a:tc>
+                <a:tc>
+                  <a:txBody>
+                    <a:bodyPr wrap="square"/>
+                    <a:lstStyle/>
+                    <a:p>
+                      <a:r>
+                        <a:rPr sz="1000" b="0">
+                          <a:solidFill>
+                            <a:srgbClr val="0B0B0B"/>
+                          </a:solidFill>
+                          <a:latin typeface="Calibri"/>
+                        </a:rPr>
+                        <a:t>112</a:t>
                       </a:r>
                     </a:p>
                   </a:txBody>
@@ -7920,51 +7921,51 @@
                           </a:solidFill>
                           <a:latin typeface="Calibri"/>
                         </a:rPr>
-                        <a:t>96</a:t>
-                      </a:r>
-                    </a:p>
-                  </a:txBody>
-                  <a:tcPr>
-                    <a:solidFill>
-                      <a:srgbClr val="FFFFFF"/>
-                    </a:solidFill>
-                  </a:tcPr>
-                </a:tc>
-                <a:tc>
-                  <a:txBody>
-                    <a:bodyPr wrap="square"/>
-                    <a:lstStyle/>
-                    <a:p>
-                      <a:r>
-                        <a:rPr sz="1000" b="0">
-                          <a:solidFill>
-                            <a:srgbClr val="0B0B0B"/>
-                          </a:solidFill>
-                          <a:latin typeface="Calibri"/>
-                        </a:rPr>
-                        <a:t>BTG Pactual (101)</a:t>
-                      </a:r>
-                    </a:p>
-                  </a:txBody>
-                  <a:tcPr>
-                    <a:solidFill>
-                      <a:srgbClr val="FFFFFF"/>
-                    </a:solidFill>
-                  </a:tcPr>
-                </a:tc>
-                <a:tc>
-                  <a:txBody>
-                    <a:bodyPr wrap="square"/>
-                    <a:lstStyle/>
-                    <a:p>
-                      <a:r>
-                        <a:rPr sz="1000" b="0">
-                          <a:solidFill>
-                            <a:srgbClr val="0B0B0B"/>
-                          </a:solidFill>
-                          <a:latin typeface="Calibri"/>
-                        </a:rPr>
-                        <a:t>60</a:t>
+                        <a:t>104</a:t>
+                      </a:r>
+                    </a:p>
+                  </a:txBody>
+                  <a:tcPr>
+                    <a:solidFill>
+                      <a:srgbClr val="FFFFFF"/>
+                    </a:solidFill>
+                  </a:tcPr>
+                </a:tc>
+                <a:tc>
+                  <a:txBody>
+                    <a:bodyPr wrap="square"/>
+                    <a:lstStyle/>
+                    <a:p>
+                      <a:r>
+                        <a:rPr sz="1000" b="0">
+                          <a:solidFill>
+                            <a:srgbClr val="0B0B0B"/>
+                          </a:solidFill>
+                          <a:latin typeface="Calibri"/>
+                        </a:rPr>
+                        <a:t>BTG Pactual (105)</a:t>
+                      </a:r>
+                    </a:p>
+                  </a:txBody>
+                  <a:tcPr>
+                    <a:solidFill>
+                      <a:srgbClr val="FFFFFF"/>
+                    </a:solidFill>
+                  </a:tcPr>
+                </a:tc>
+                <a:tc>
+                  <a:txBody>
+                    <a:bodyPr wrap="square"/>
+                    <a:lstStyle/>
+                    <a:p>
+                      <a:r>
+                        <a:rPr sz="1000" b="0">
+                          <a:solidFill>
+                            <a:srgbClr val="0B0B0B"/>
+                          </a:solidFill>
+                          <a:latin typeface="Calibri"/>
+                        </a:rPr>
+                        <a:t>63</a:t>
                       </a:r>
                     </a:p>
                   </a:txBody>
@@ -7988,73 +7989,73 @@
                           </a:solidFill>
                           <a:latin typeface="Calibri"/>
                         </a:rPr>
-                        <a:t>Multimercado</a:t>
-                      </a:r>
-                    </a:p>
-                  </a:txBody>
-                  <a:tcPr>
-                    <a:solidFill>
-                      <a:srgbClr val="FFFFFF"/>
-                    </a:solidFill>
-                  </a:tcPr>
-                </a:tc>
-                <a:tc>
-                  <a:txBody>
-                    <a:bodyPr wrap="square"/>
-                    <a:lstStyle/>
-                    <a:p>
-                      <a:r>
-                        <a:rPr sz="1000" b="0">
-                          <a:solidFill>
-                            <a:srgbClr val="0B0B0B"/>
-                          </a:solidFill>
-                          <a:latin typeface="Calibri"/>
-                        </a:rPr>
-                        <a:t>9</a:t>
-                      </a:r>
-                    </a:p>
-                  </a:txBody>
-                  <a:tcPr>
-                    <a:solidFill>
-                      <a:srgbClr val="FFFFFF"/>
-                    </a:solidFill>
-                  </a:tcPr>
-                </a:tc>
-                <a:tc>
-                  <a:txBody>
-                    <a:bodyPr wrap="square"/>
-                    <a:lstStyle/>
-                    <a:p>
-                      <a:r>
-                        <a:rPr sz="1000" b="0">
-                          <a:solidFill>
-                            <a:srgbClr val="0B0B0B"/>
-                          </a:solidFill>
-                          <a:latin typeface="Calibri"/>
-                        </a:rPr>
-                        <a:t>Itau (Ion) (169)</a:t>
-                      </a:r>
-                    </a:p>
-                  </a:txBody>
-                  <a:tcPr>
-                    <a:solidFill>
-                      <a:srgbClr val="FFFFFF"/>
-                    </a:solidFill>
-                  </a:tcPr>
-                </a:tc>
-                <a:tc>
-                  <a:txBody>
-                    <a:bodyPr wrap="square"/>
-                    <a:lstStyle/>
-                    <a:p>
-                      <a:r>
-                        <a:rPr sz="1000" b="0">
-                          <a:solidFill>
-                            <a:srgbClr val="0B0B0B"/>
-                          </a:solidFill>
-                          <a:latin typeface="Calibri"/>
-                        </a:rPr>
-                        <a:t>51</a:t>
+                        <a:t>Multimercados Macro</a:t>
+                      </a:r>
+                    </a:p>
+                  </a:txBody>
+                  <a:tcPr>
+                    <a:solidFill>
+                      <a:srgbClr val="FFFFFF"/>
+                    </a:solidFill>
+                  </a:tcPr>
+                </a:tc>
+                <a:tc>
+                  <a:txBody>
+                    <a:bodyPr wrap="square"/>
+                    <a:lstStyle/>
+                    <a:p>
+                      <a:r>
+                        <a:rPr sz="1000" b="0">
+                          <a:solidFill>
+                            <a:srgbClr val="0B0B0B"/>
+                          </a:solidFill>
+                          <a:latin typeface="Calibri"/>
+                        </a:rPr>
+                        <a:t>44</a:t>
+                      </a:r>
+                    </a:p>
+                  </a:txBody>
+                  <a:tcPr>
+                    <a:solidFill>
+                      <a:srgbClr val="FFFFFF"/>
+                    </a:solidFill>
+                  </a:tcPr>
+                </a:tc>
+                <a:tc>
+                  <a:txBody>
+                    <a:bodyPr wrap="square"/>
+                    <a:lstStyle/>
+                    <a:p>
+                      <a:r>
+                        <a:rPr sz="1000" b="0">
+                          <a:solidFill>
+                            <a:srgbClr val="0B0B0B"/>
+                          </a:solidFill>
+                          <a:latin typeface="Calibri"/>
+                        </a:rPr>
+                        <a:t>Banco Inter (53)</a:t>
+                      </a:r>
+                    </a:p>
+                  </a:txBody>
+                  <a:tcPr>
+                    <a:solidFill>
+                      <a:srgbClr val="FFFFFF"/>
+                    </a:solidFill>
+                  </a:tcPr>
+                </a:tc>
+                <a:tc>
+                  <a:txBody>
+                    <a:bodyPr wrap="square"/>
+                    <a:lstStyle/>
+                    <a:p>
+                      <a:r>
+                        <a:rPr sz="1000" b="0">
+                          <a:solidFill>
+                            <a:srgbClr val="0B0B0B"/>
+                          </a:solidFill>
+                          <a:latin typeface="Calibri"/>
+                        </a:rPr>
+                        <a:t>52</a:t>
                       </a:r>
                     </a:p>
                   </a:txBody>
@@ -8078,73 +8079,73 @@
                           </a:solidFill>
                           <a:latin typeface="Calibri"/>
                         </a:rPr>
-                        <a:t>Multimercados Macro</a:t>
-                      </a:r>
-                    </a:p>
-                  </a:txBody>
-                  <a:tcPr>
-                    <a:solidFill>
-                      <a:srgbClr val="FFFFFF"/>
-                    </a:solidFill>
-                  </a:tcPr>
-                </a:tc>
-                <a:tc>
-                  <a:txBody>
-                    <a:bodyPr wrap="square"/>
-                    <a:lstStyle/>
-                    <a:p>
-                      <a:r>
-                        <a:rPr sz="1000" b="0">
-                          <a:solidFill>
-                            <a:srgbClr val="0B0B0B"/>
-                          </a:solidFill>
-                          <a:latin typeface="Calibri"/>
-                        </a:rPr>
-                        <a:t>40</a:t>
-                      </a:r>
-                    </a:p>
-                  </a:txBody>
-                  <a:tcPr>
-                    <a:solidFill>
-                      <a:srgbClr val="FFFFFF"/>
-                    </a:solidFill>
-                  </a:tcPr>
-                </a:tc>
-                <a:tc>
-                  <a:txBody>
-                    <a:bodyPr wrap="square"/>
-                    <a:lstStyle/>
-                    <a:p>
-                      <a:r>
-                        <a:rPr sz="1000" b="0">
-                          <a:solidFill>
-                            <a:srgbClr val="0B0B0B"/>
-                          </a:solidFill>
-                          <a:latin typeface="Calibri"/>
-                        </a:rPr>
-                        <a:t>Banco Inter (42)</a:t>
-                      </a:r>
-                    </a:p>
-                  </a:txBody>
-                  <a:tcPr>
-                    <a:solidFill>
-                      <a:srgbClr val="FFFFFF"/>
-                    </a:solidFill>
-                  </a:tcPr>
-                </a:tc>
-                <a:tc>
-                  <a:txBody>
-                    <a:bodyPr wrap="square"/>
-                    <a:lstStyle/>
-                    <a:p>
-                      <a:r>
-                        <a:rPr sz="1000" b="0">
-                          <a:solidFill>
-                            <a:srgbClr val="0B0B0B"/>
-                          </a:solidFill>
-                          <a:latin typeface="Calibri"/>
-                        </a:rPr>
-                        <a:t>41</a:t>
+                        <a:t>Multimercados Invest. no Exterior</a:t>
+                      </a:r>
+                    </a:p>
+                  </a:txBody>
+                  <a:tcPr>
+                    <a:solidFill>
+                      <a:srgbClr val="FFFFFF"/>
+                    </a:solidFill>
+                  </a:tcPr>
+                </a:tc>
+                <a:tc>
+                  <a:txBody>
+                    <a:bodyPr wrap="square"/>
+                    <a:lstStyle/>
+                    <a:p>
+                      <a:r>
+                        <a:rPr sz="1000" b="0">
+                          <a:solidFill>
+                            <a:srgbClr val="0B0B0B"/>
+                          </a:solidFill>
+                          <a:latin typeface="Calibri"/>
+                        </a:rPr>
+                        <a:t>31</a:t>
+                      </a:r>
+                    </a:p>
+                  </a:txBody>
+                  <a:tcPr>
+                    <a:solidFill>
+                      <a:srgbClr val="FFFFFF"/>
+                    </a:solidFill>
+                  </a:tcPr>
+                </a:tc>
+                <a:tc>
+                  <a:txBody>
+                    <a:bodyPr wrap="square"/>
+                    <a:lstStyle/>
+                    <a:p>
+                      <a:r>
+                        <a:rPr sz="1000" b="0">
+                          <a:solidFill>
+                            <a:srgbClr val="0B0B0B"/>
+                          </a:solidFill>
+                          <a:latin typeface="Calibri"/>
+                        </a:rPr>
+                        <a:t>BTG Pactual (45)</a:t>
+                      </a:r>
+                    </a:p>
+                  </a:txBody>
+                  <a:tcPr>
+                    <a:solidFill>
+                      <a:srgbClr val="FFFFFF"/>
+                    </a:solidFill>
+                  </a:tcPr>
+                </a:tc>
+                <a:tc>
+                  <a:txBody>
+                    <a:bodyPr wrap="square"/>
+                    <a:lstStyle/>
+                    <a:p>
+                      <a:r>
+                        <a:rPr sz="1000" b="0">
+                          <a:solidFill>
+                            <a:srgbClr val="0B0B0B"/>
+                          </a:solidFill>
+                          <a:latin typeface="Calibri"/>
+                        </a:rPr>
+                        <a:t>48</a:t>
                       </a:r>
                     </a:p>
                   </a:txBody>
@@ -8600,7 +8601,7 @@
         <p:spPr>
           <a:xfrm>
             <a:off x="2743200" y="2103120"/>
-            <a:ext cx="1251626" cy="274320"/>
+            <a:ext cx="1239783" cy="274320"/>
           </a:xfrm>
           <a:prstGeom prst="rect">
             <a:avLst/>
@@ -8643,7 +8644,7 @@
         </p:nvSpPr>
         <p:spPr>
           <a:xfrm>
-            <a:off x="4022258" y="2103120"/>
+            <a:off x="4010415" y="2103120"/>
             <a:ext cx="6249428" cy="274320"/>
           </a:xfrm>
           <a:prstGeom prst="rect">
@@ -8687,8 +8688,8 @@
         </p:nvSpPr>
         <p:spPr>
           <a:xfrm>
-            <a:off x="10299118" y="2103120"/>
-            <a:ext cx="280489" cy="274320"/>
+            <a:off x="10287275" y="2103120"/>
+            <a:ext cx="292332" cy="274320"/>
           </a:xfrm>
           <a:prstGeom prst="rect">
             <a:avLst/>
@@ -8800,7 +8801,7 @@
         <p:spPr>
           <a:xfrm>
             <a:off x="2743200" y="2670048"/>
-            <a:ext cx="1358214" cy="274320"/>
+            <a:ext cx="1381900" cy="274320"/>
           </a:xfrm>
           <a:prstGeom prst="rect">
             <a:avLst/>
@@ -8843,8 +8844,8 @@
         </p:nvSpPr>
         <p:spPr>
           <a:xfrm>
-            <a:off x="4128846" y="2670048"/>
-            <a:ext cx="6095467" cy="274320"/>
+            <a:off x="4152532" y="2670048"/>
+            <a:ext cx="6071781" cy="274320"/>
           </a:xfrm>
           <a:prstGeom prst="rect">
             <a:avLst/>
@@ -8956,7 +8957,7 @@
         <p:spPr>
           <a:xfrm>
             <a:off x="2743200" y="3236976"/>
-            <a:ext cx="1879312" cy="274320"/>
+            <a:ext cx="1867469" cy="274320"/>
           </a:xfrm>
           <a:prstGeom prst="rect">
             <a:avLst/>
@@ -8999,8 +9000,8 @@
         </p:nvSpPr>
         <p:spPr>
           <a:xfrm>
-            <a:off x="4649944" y="3236976"/>
-            <a:ext cx="3489978" cy="274320"/>
+            <a:off x="4638101" y="3236976"/>
+            <a:ext cx="3501821" cy="274320"/>
           </a:xfrm>
           <a:prstGeom prst="rect">
             <a:avLst/>
@@ -10956,6 +10957,1263 @@
                 </a:solidFill>
                 <a:latin typeface="Calibri"/>
               </a:rPr>
+              <a:t>Radar CVM - visao antecipada</a:t>
+            </a:r>
+          </a:p>
+        </p:txBody>
+      </p:sp>
+      <p:sp>
+        <p:nvSpPr>
+          <p:cNvPr id="4" name="TextBox 3"/>
+          <p:cNvSpPr txBox="1"/>
+          <p:nvPr/>
+        </p:nvSpPr>
+        <p:spPr>
+          <a:xfrm>
+            <a:off x="548640" y="868680"/>
+            <a:ext cx="11064240" cy="457200"/>
+          </a:xfrm>
+          <a:prstGeom prst="rect">
+            <a:avLst/>
+          </a:prstGeom>
+          <a:noFill/>
+        </p:spPr>
+        <p:txBody>
+          <a:bodyPr wrap="square">
+            <a:spAutoFit/>
+          </a:bodyPr>
+          <a:lstStyle/>
+          <a:p>
+            <a:r>
+              <a:rPr sz="1200" b="0">
+                <a:solidFill>
+                  <a:srgbClr val="52514E"/>
+                </a:solidFill>
+                <a:latin typeface="Calibri"/>
+              </a:rPr>
+              <a:t>Fundos registrados por gestoras ligadas as casas; pre-operacional = registrado e ainda nao lancado</a:t>
+            </a:r>
+          </a:p>
+        </p:txBody>
+      </p:sp>
+      <p:graphicFrame>
+        <p:nvGraphicFramePr>
+          <p:cNvPr id="5" name="Table 4"/>
+          <p:cNvGraphicFramePr>
+            <a:graphicFrameLocks noGrp="1"/>
+          </p:cNvGraphicFramePr>
+          <p:nvPr/>
+        </p:nvGraphicFramePr>
+        <p:xfrm>
+          <a:off x="548640" y="1463040"/>
+          <a:ext cx="6857998" cy="1755648"/>
+        </p:xfrm>
+        <a:graphic>
+          <a:graphicData uri="http://schemas.openxmlformats.org/drawingml/2006/table">
+            <a:tbl>
+              <a:tblPr>
+                <a:tableStyleId>{5C22544A-7EE6-4342-B048-85BDC9FD1C3A}</a:tableStyleId>
+              </a:tblPr>
+              <a:tblGrid>
+                <a:gridCol w="3117272"/>
+                <a:gridCol w="1870363"/>
+                <a:gridCol w="1870363"/>
+              </a:tblGrid>
+              <a:tr h="292608">
+                <a:tc>
+                  <a:txBody>
+                    <a:bodyPr wrap="square"/>
+                    <a:lstStyle/>
+                    <a:p>
+                      <a:r>
+                        <a:rPr sz="1100" b="1">
+                          <a:solidFill>
+                            <a:srgbClr val="52514E"/>
+                          </a:solidFill>
+                          <a:latin typeface="Calibri"/>
+                        </a:rPr>
+                        <a:t>Casa</a:t>
+                      </a:r>
+                    </a:p>
+                  </a:txBody>
+                  <a:tcPr>
+                    <a:solidFill>
+                      <a:srgbClr val="F1F0EC"/>
+                    </a:solidFill>
+                  </a:tcPr>
+                </a:tc>
+                <a:tc>
+                  <a:txBody>
+                    <a:bodyPr wrap="square"/>
+                    <a:lstStyle/>
+                    <a:p>
+                      <a:r>
+                        <a:rPr sz="1100" b="1">
+                          <a:solidFill>
+                            <a:srgbClr val="52514E"/>
+                          </a:solidFill>
+                          <a:latin typeface="Calibri"/>
+                        </a:rPr>
+                        <a:t>Registrados</a:t>
+                      </a:r>
+                    </a:p>
+                  </a:txBody>
+                  <a:tcPr>
+                    <a:solidFill>
+                      <a:srgbClr val="F1F0EC"/>
+                    </a:solidFill>
+                  </a:tcPr>
+                </a:tc>
+                <a:tc>
+                  <a:txBody>
+                    <a:bodyPr wrap="square"/>
+                    <a:lstStyle/>
+                    <a:p>
+                      <a:r>
+                        <a:rPr sz="1100" b="1">
+                          <a:solidFill>
+                            <a:srgbClr val="52514E"/>
+                          </a:solidFill>
+                          <a:latin typeface="Calibri"/>
+                        </a:rPr>
+                        <a:t>Pre-operacionais</a:t>
+                      </a:r>
+                    </a:p>
+                  </a:txBody>
+                  <a:tcPr>
+                    <a:solidFill>
+                      <a:srgbClr val="F1F0EC"/>
+                    </a:solidFill>
+                  </a:tcPr>
+                </a:tc>
+              </a:tr>
+              <a:tr h="292608">
+                <a:tc>
+                  <a:txBody>
+                    <a:bodyPr wrap="square"/>
+                    <a:lstStyle/>
+                    <a:p>
+                      <a:r>
+                        <a:rPr sz="1100" b="0">
+                          <a:solidFill>
+                            <a:srgbClr val="0B0B0B"/>
+                          </a:solidFill>
+                          <a:latin typeface="Calibri"/>
+                        </a:rPr>
+                        <a:t>BTG Pactual</a:t>
+                      </a:r>
+                    </a:p>
+                  </a:txBody>
+                  <a:tcPr>
+                    <a:solidFill>
+                      <a:srgbClr val="FFFFFF"/>
+                    </a:solidFill>
+                  </a:tcPr>
+                </a:tc>
+                <a:tc>
+                  <a:txBody>
+                    <a:bodyPr wrap="square"/>
+                    <a:lstStyle/>
+                    <a:p>
+                      <a:r>
+                        <a:rPr sz="1100" b="0">
+                          <a:solidFill>
+                            <a:srgbClr val="0B0B0B"/>
+                          </a:solidFill>
+                          <a:latin typeface="Calibri"/>
+                        </a:rPr>
+                        <a:t>4.404</a:t>
+                      </a:r>
+                    </a:p>
+                  </a:txBody>
+                  <a:tcPr>
+                    <a:solidFill>
+                      <a:srgbClr val="FFFFFF"/>
+                    </a:solidFill>
+                  </a:tcPr>
+                </a:tc>
+                <a:tc>
+                  <a:txBody>
+                    <a:bodyPr wrap="square"/>
+                    <a:lstStyle/>
+                    <a:p>
+                      <a:r>
+                        <a:rPr sz="1100" b="0">
+                          <a:solidFill>
+                            <a:srgbClr val="0B0B0B"/>
+                          </a:solidFill>
+                          <a:latin typeface="Calibri"/>
+                        </a:rPr>
+                        <a:t>84</a:t>
+                      </a:r>
+                    </a:p>
+                  </a:txBody>
+                  <a:tcPr>
+                    <a:solidFill>
+                      <a:srgbClr val="FFFFFF"/>
+                    </a:solidFill>
+                  </a:tcPr>
+                </a:tc>
+              </a:tr>
+              <a:tr h="292608">
+                <a:tc>
+                  <a:txBody>
+                    <a:bodyPr wrap="square"/>
+                    <a:lstStyle/>
+                    <a:p>
+                      <a:r>
+                        <a:rPr sz="1100" b="0">
+                          <a:solidFill>
+                            <a:srgbClr val="0B0B0B"/>
+                          </a:solidFill>
+                          <a:latin typeface="Calibri"/>
+                        </a:rPr>
+                        <a:t>Banco Inter</a:t>
+                      </a:r>
+                    </a:p>
+                  </a:txBody>
+                  <a:tcPr>
+                    <a:solidFill>
+                      <a:srgbClr val="FFFFFF"/>
+                    </a:solidFill>
+                  </a:tcPr>
+                </a:tc>
+                <a:tc>
+                  <a:txBody>
+                    <a:bodyPr wrap="square"/>
+                    <a:lstStyle/>
+                    <a:p>
+                      <a:r>
+                        <a:rPr sz="1100" b="0">
+                          <a:solidFill>
+                            <a:srgbClr val="0B0B0B"/>
+                          </a:solidFill>
+                          <a:latin typeface="Calibri"/>
+                        </a:rPr>
+                        <a:t>159</a:t>
+                      </a:r>
+                    </a:p>
+                  </a:txBody>
+                  <a:tcPr>
+                    <a:solidFill>
+                      <a:srgbClr val="FFFFFF"/>
+                    </a:solidFill>
+                  </a:tcPr>
+                </a:tc>
+                <a:tc>
+                  <a:txBody>
+                    <a:bodyPr wrap="square"/>
+                    <a:lstStyle/>
+                    <a:p>
+                      <a:r>
+                        <a:rPr sz="1100" b="0">
+                          <a:solidFill>
+                            <a:srgbClr val="0B0B0B"/>
+                          </a:solidFill>
+                          <a:latin typeface="Calibri"/>
+                        </a:rPr>
+                        <a:t>2</a:t>
+                      </a:r>
+                    </a:p>
+                  </a:txBody>
+                  <a:tcPr>
+                    <a:solidFill>
+                      <a:srgbClr val="FFFFFF"/>
+                    </a:solidFill>
+                  </a:tcPr>
+                </a:tc>
+              </a:tr>
+              <a:tr h="292608">
+                <a:tc>
+                  <a:txBody>
+                    <a:bodyPr wrap="square"/>
+                    <a:lstStyle/>
+                    <a:p>
+                      <a:r>
+                        <a:rPr sz="1100" b="0">
+                          <a:solidFill>
+                            <a:srgbClr val="0B0B0B"/>
+                          </a:solidFill>
+                          <a:latin typeface="Calibri"/>
+                        </a:rPr>
+                        <a:t>Itau (Ion)</a:t>
+                      </a:r>
+                    </a:p>
+                  </a:txBody>
+                  <a:tcPr>
+                    <a:solidFill>
+                      <a:srgbClr val="FFFFFF"/>
+                    </a:solidFill>
+                  </a:tcPr>
+                </a:tc>
+                <a:tc>
+                  <a:txBody>
+                    <a:bodyPr wrap="square"/>
+                    <a:lstStyle/>
+                    <a:p>
+                      <a:r>
+                        <a:rPr sz="1100" b="0">
+                          <a:solidFill>
+                            <a:srgbClr val="0B0B0B"/>
+                          </a:solidFill>
+                          <a:latin typeface="Calibri"/>
+                        </a:rPr>
+                        <a:t>5.045</a:t>
+                      </a:r>
+                    </a:p>
+                  </a:txBody>
+                  <a:tcPr>
+                    <a:solidFill>
+                      <a:srgbClr val="FFFFFF"/>
+                    </a:solidFill>
+                  </a:tcPr>
+                </a:tc>
+                <a:tc>
+                  <a:txBody>
+                    <a:bodyPr wrap="square"/>
+                    <a:lstStyle/>
+                    <a:p>
+                      <a:r>
+                        <a:rPr sz="1100" b="0">
+                          <a:solidFill>
+                            <a:srgbClr val="0B0B0B"/>
+                          </a:solidFill>
+                          <a:latin typeface="Calibri"/>
+                        </a:rPr>
+                        <a:t>219</a:t>
+                      </a:r>
+                    </a:p>
+                  </a:txBody>
+                  <a:tcPr>
+                    <a:solidFill>
+                      <a:srgbClr val="FFFFFF"/>
+                    </a:solidFill>
+                  </a:tcPr>
+                </a:tc>
+              </a:tr>
+              <a:tr h="292608">
+                <a:tc>
+                  <a:txBody>
+                    <a:bodyPr wrap="square"/>
+                    <a:lstStyle/>
+                    <a:p>
+                      <a:r>
+                        <a:rPr sz="1100" b="0">
+                          <a:solidFill>
+                            <a:srgbClr val="0B0B0B"/>
+                          </a:solidFill>
+                          <a:latin typeface="Calibri"/>
+                        </a:rPr>
+                        <a:t>Nu (Nubank)</a:t>
+                      </a:r>
+                    </a:p>
+                  </a:txBody>
+                  <a:tcPr>
+                    <a:solidFill>
+                      <a:srgbClr val="FFFFFF"/>
+                    </a:solidFill>
+                  </a:tcPr>
+                </a:tc>
+                <a:tc>
+                  <a:txBody>
+                    <a:bodyPr wrap="square"/>
+                    <a:lstStyle/>
+                    <a:p>
+                      <a:r>
+                        <a:rPr sz="1100" b="0">
+                          <a:solidFill>
+                            <a:srgbClr val="0B0B0B"/>
+                          </a:solidFill>
+                          <a:latin typeface="Calibri"/>
+                        </a:rPr>
+                        <a:t>50</a:t>
+                      </a:r>
+                    </a:p>
+                  </a:txBody>
+                  <a:tcPr>
+                    <a:solidFill>
+                      <a:srgbClr val="FFFFFF"/>
+                    </a:solidFill>
+                  </a:tcPr>
+                </a:tc>
+                <a:tc>
+                  <a:txBody>
+                    <a:bodyPr wrap="square"/>
+                    <a:lstStyle/>
+                    <a:p>
+                      <a:r>
+                        <a:rPr sz="1100" b="0">
+                          <a:solidFill>
+                            <a:srgbClr val="0B0B0B"/>
+                          </a:solidFill>
+                          <a:latin typeface="Calibri"/>
+                        </a:rPr>
+                        <a:t>4</a:t>
+                      </a:r>
+                    </a:p>
+                  </a:txBody>
+                  <a:tcPr>
+                    <a:solidFill>
+                      <a:srgbClr val="FFFFFF"/>
+                    </a:solidFill>
+                  </a:tcPr>
+                </a:tc>
+              </a:tr>
+              <a:tr h="292608">
+                <a:tc>
+                  <a:txBody>
+                    <a:bodyPr wrap="square"/>
+                    <a:lstStyle/>
+                    <a:p>
+                      <a:r>
+                        <a:rPr sz="1100" b="0">
+                          <a:solidFill>
+                            <a:srgbClr val="0B0B0B"/>
+                          </a:solidFill>
+                          <a:latin typeface="Calibri"/>
+                        </a:rPr>
+                        <a:t>XP Investimentos</a:t>
+                      </a:r>
+                    </a:p>
+                  </a:txBody>
+                  <a:tcPr>
+                    <a:solidFill>
+                      <a:srgbClr val="FFFFFF"/>
+                    </a:solidFill>
+                  </a:tcPr>
+                </a:tc>
+                <a:tc>
+                  <a:txBody>
+                    <a:bodyPr wrap="square"/>
+                    <a:lstStyle/>
+                    <a:p>
+                      <a:r>
+                        <a:rPr sz="1100" b="0">
+                          <a:solidFill>
+                            <a:srgbClr val="0B0B0B"/>
+                          </a:solidFill>
+                          <a:latin typeface="Calibri"/>
+                        </a:rPr>
+                        <a:t>2.178</a:t>
+                      </a:r>
+                    </a:p>
+                  </a:txBody>
+                  <a:tcPr>
+                    <a:solidFill>
+                      <a:srgbClr val="FFFFFF"/>
+                    </a:solidFill>
+                  </a:tcPr>
+                </a:tc>
+                <a:tc>
+                  <a:txBody>
+                    <a:bodyPr wrap="square"/>
+                    <a:lstStyle/>
+                    <a:p>
+                      <a:r>
+                        <a:rPr sz="1100" b="0">
+                          <a:solidFill>
+                            <a:srgbClr val="0B0B0B"/>
+                          </a:solidFill>
+                          <a:latin typeface="Calibri"/>
+                        </a:rPr>
+                        <a:t>69</a:t>
+                      </a:r>
+                    </a:p>
+                  </a:txBody>
+                  <a:tcPr>
+                    <a:solidFill>
+                      <a:srgbClr val="FFFFFF"/>
+                    </a:solidFill>
+                  </a:tcPr>
+                </a:tc>
+              </a:tr>
+            </a:tbl>
+          </a:graphicData>
+        </a:graphic>
+      </p:graphicFrame>
+      <p:sp>
+        <p:nvSpPr>
+          <p:cNvPr id="6" name="TextBox 5"/>
+          <p:cNvSpPr txBox="1"/>
+          <p:nvPr/>
+        </p:nvSpPr>
+        <p:spPr>
+          <a:xfrm>
+            <a:off x="548640" y="3584448"/>
+            <a:ext cx="10972800" cy="365760"/>
+          </a:xfrm>
+          <a:prstGeom prst="rect">
+            <a:avLst/>
+          </a:prstGeom>
+          <a:noFill/>
+        </p:spPr>
+        <p:txBody>
+          <a:bodyPr wrap="square">
+            <a:spAutoFit/>
+          </a:bodyPr>
+          <a:lstStyle/>
+          <a:p>
+            <a:r>
+              <a:rPr sz="1300" b="1">
+                <a:solidFill>
+                  <a:srgbClr val="0B0B0B"/>
+                </a:solidFill>
+                <a:latin typeface="Calibri"/>
+              </a:rPr>
+              <a:t>Registros pre-operacionais mais recentes</a:t>
+            </a:r>
+          </a:p>
+        </p:txBody>
+      </p:sp>
+      <p:graphicFrame>
+        <p:nvGraphicFramePr>
+          <p:cNvPr id="7" name="Table 6"/>
+          <p:cNvGraphicFramePr>
+            <a:graphicFrameLocks noGrp="1"/>
+          </p:cNvGraphicFramePr>
+          <p:nvPr/>
+        </p:nvGraphicFramePr>
+        <p:xfrm>
+          <a:off x="548640" y="3995928"/>
+          <a:ext cx="11064239" cy="2048256"/>
+        </p:xfrm>
+        <a:graphic>
+          <a:graphicData uri="http://schemas.openxmlformats.org/drawingml/2006/table">
+            <a:tbl>
+              <a:tblPr>
+                <a:tableStyleId>{5C22544A-7EE6-4342-B048-85BDC9FD1C3A}</a:tableStyleId>
+              </a:tblPr>
+              <a:tblGrid>
+                <a:gridCol w="5423647"/>
+                <a:gridCol w="1518621"/>
+                <a:gridCol w="2820296"/>
+                <a:gridCol w="1301675"/>
+              </a:tblGrid>
+              <a:tr h="292608">
+                <a:tc>
+                  <a:txBody>
+                    <a:bodyPr wrap="square"/>
+                    <a:lstStyle/>
+                    <a:p>
+                      <a:r>
+                        <a:rPr sz="900" b="1">
+                          <a:solidFill>
+                            <a:srgbClr val="52514E"/>
+                          </a:solidFill>
+                          <a:latin typeface="Calibri"/>
+                        </a:rPr>
+                        <a:t>Fundo</a:t>
+                      </a:r>
+                    </a:p>
+                  </a:txBody>
+                  <a:tcPr>
+                    <a:solidFill>
+                      <a:srgbClr val="F1F0EC"/>
+                    </a:solidFill>
+                  </a:tcPr>
+                </a:tc>
+                <a:tc>
+                  <a:txBody>
+                    <a:bodyPr wrap="square"/>
+                    <a:lstStyle/>
+                    <a:p>
+                      <a:r>
+                        <a:rPr sz="900" b="1">
+                          <a:solidFill>
+                            <a:srgbClr val="52514E"/>
+                          </a:solidFill>
+                          <a:latin typeface="Calibri"/>
+                        </a:rPr>
+                        <a:t>Casa</a:t>
+                      </a:r>
+                    </a:p>
+                  </a:txBody>
+                  <a:tcPr>
+                    <a:solidFill>
+                      <a:srgbClr val="F1F0EC"/>
+                    </a:solidFill>
+                  </a:tcPr>
+                </a:tc>
+                <a:tc>
+                  <a:txBody>
+                    <a:bodyPr wrap="square"/>
+                    <a:lstStyle/>
+                    <a:p>
+                      <a:r>
+                        <a:rPr sz="900" b="1">
+                          <a:solidFill>
+                            <a:srgbClr val="52514E"/>
+                          </a:solidFill>
+                          <a:latin typeface="Calibri"/>
+                        </a:rPr>
+                        <a:t>Gestora</a:t>
+                      </a:r>
+                    </a:p>
+                  </a:txBody>
+                  <a:tcPr>
+                    <a:solidFill>
+                      <a:srgbClr val="F1F0EC"/>
+                    </a:solidFill>
+                  </a:tcPr>
+                </a:tc>
+                <a:tc>
+                  <a:txBody>
+                    <a:bodyPr wrap="square"/>
+                    <a:lstStyle/>
+                    <a:p>
+                      <a:r>
+                        <a:rPr sz="900" b="1">
+                          <a:solidFill>
+                            <a:srgbClr val="52514E"/>
+                          </a:solidFill>
+                          <a:latin typeface="Calibri"/>
+                        </a:rPr>
+                        <a:t>Registro</a:t>
+                      </a:r>
+                    </a:p>
+                  </a:txBody>
+                  <a:tcPr>
+                    <a:solidFill>
+                      <a:srgbClr val="F1F0EC"/>
+                    </a:solidFill>
+                  </a:tcPr>
+                </a:tc>
+              </a:tr>
+              <a:tr h="292608">
+                <a:tc>
+                  <a:txBody>
+                    <a:bodyPr wrap="square"/>
+                    <a:lstStyle/>
+                    <a:p>
+                      <a:r>
+                        <a:rPr sz="900" b="0">
+                          <a:solidFill>
+                            <a:srgbClr val="0B0B0B"/>
+                          </a:solidFill>
+                          <a:latin typeface="Calibri"/>
+                        </a:rPr>
+                        <a:t>XP CDI 94 CRA I FIAGRO RESPONSABILIDADE LIMITADA</a:t>
+                      </a:r>
+                    </a:p>
+                  </a:txBody>
+                  <a:tcPr>
+                    <a:solidFill>
+                      <a:srgbClr val="FFFFFF"/>
+                    </a:solidFill>
+                  </a:tcPr>
+                </a:tc>
+                <a:tc>
+                  <a:txBody>
+                    <a:bodyPr wrap="square"/>
+                    <a:lstStyle/>
+                    <a:p>
+                      <a:r>
+                        <a:rPr sz="900" b="0">
+                          <a:solidFill>
+                            <a:srgbClr val="0B0B0B"/>
+                          </a:solidFill>
+                          <a:latin typeface="Calibri"/>
+                        </a:rPr>
+                        <a:t>XP Investimentos</a:t>
+                      </a:r>
+                    </a:p>
+                  </a:txBody>
+                  <a:tcPr>
+                    <a:solidFill>
+                      <a:srgbClr val="FFFFFF"/>
+                    </a:solidFill>
+                  </a:tcPr>
+                </a:tc>
+                <a:tc>
+                  <a:txBody>
+                    <a:bodyPr wrap="square"/>
+                    <a:lstStyle/>
+                    <a:p>
+                      <a:r>
+                        <a:rPr sz="900" b="0">
+                          <a:solidFill>
+                            <a:srgbClr val="0B0B0B"/>
+                          </a:solidFill>
+                          <a:latin typeface="Calibri"/>
+                        </a:rPr>
+                        <a:t>XP VISTA ASSET MANAGEMENT LTDA.</a:t>
+                      </a:r>
+                    </a:p>
+                  </a:txBody>
+                  <a:tcPr>
+                    <a:solidFill>
+                      <a:srgbClr val="FFFFFF"/>
+                    </a:solidFill>
+                  </a:tcPr>
+                </a:tc>
+                <a:tc>
+                  <a:txBody>
+                    <a:bodyPr wrap="square"/>
+                    <a:lstStyle/>
+                    <a:p>
+                      <a:r>
+                        <a:rPr sz="900" b="0">
+                          <a:solidFill>
+                            <a:srgbClr val="0B0B0B"/>
+                          </a:solidFill>
+                          <a:latin typeface="Calibri"/>
+                        </a:rPr>
+                        <a:t>2026-09-18</a:t>
+                      </a:r>
+                    </a:p>
+                  </a:txBody>
+                  <a:tcPr>
+                    <a:solidFill>
+                      <a:srgbClr val="FFFFFF"/>
+                    </a:solidFill>
+                  </a:tcPr>
+                </a:tc>
+              </a:tr>
+              <a:tr h="292608">
+                <a:tc>
+                  <a:txBody>
+                    <a:bodyPr wrap="square"/>
+                    <a:lstStyle/>
+                    <a:p>
+                      <a:r>
+                        <a:rPr sz="900" b="0">
+                          <a:solidFill>
+                            <a:srgbClr val="0B0B0B"/>
+                          </a:solidFill>
+                          <a:latin typeface="Calibri"/>
+                        </a:rPr>
+                        <a:t>XP CDI 95 CRA I FIAGRO RESPONSABILIDADE LIMITADA</a:t>
+                      </a:r>
+                    </a:p>
+                  </a:txBody>
+                  <a:tcPr>
+                    <a:solidFill>
+                      <a:srgbClr val="FFFFFF"/>
+                    </a:solidFill>
+                  </a:tcPr>
+                </a:tc>
+                <a:tc>
+                  <a:txBody>
+                    <a:bodyPr wrap="square"/>
+                    <a:lstStyle/>
+                    <a:p>
+                      <a:r>
+                        <a:rPr sz="900" b="0">
+                          <a:solidFill>
+                            <a:srgbClr val="0B0B0B"/>
+                          </a:solidFill>
+                          <a:latin typeface="Calibri"/>
+                        </a:rPr>
+                        <a:t>XP Investimentos</a:t>
+                      </a:r>
+                    </a:p>
+                  </a:txBody>
+                  <a:tcPr>
+                    <a:solidFill>
+                      <a:srgbClr val="FFFFFF"/>
+                    </a:solidFill>
+                  </a:tcPr>
+                </a:tc>
+                <a:tc>
+                  <a:txBody>
+                    <a:bodyPr wrap="square"/>
+                    <a:lstStyle/>
+                    <a:p>
+                      <a:r>
+                        <a:rPr sz="900" b="0">
+                          <a:solidFill>
+                            <a:srgbClr val="0B0B0B"/>
+                          </a:solidFill>
+                          <a:latin typeface="Calibri"/>
+                        </a:rPr>
+                        <a:t>XP VISTA ASSET MANAGEMENT LTDA.</a:t>
+                      </a:r>
+                    </a:p>
+                  </a:txBody>
+                  <a:tcPr>
+                    <a:solidFill>
+                      <a:srgbClr val="FFFFFF"/>
+                    </a:solidFill>
+                  </a:tcPr>
+                </a:tc>
+                <a:tc>
+                  <a:txBody>
+                    <a:bodyPr wrap="square"/>
+                    <a:lstStyle/>
+                    <a:p>
+                      <a:r>
+                        <a:rPr sz="900" b="0">
+                          <a:solidFill>
+                            <a:srgbClr val="0B0B0B"/>
+                          </a:solidFill>
+                          <a:latin typeface="Calibri"/>
+                        </a:rPr>
+                        <a:t>2026-09-18</a:t>
+                      </a:r>
+                    </a:p>
+                  </a:txBody>
+                  <a:tcPr>
+                    <a:solidFill>
+                      <a:srgbClr val="FFFFFF"/>
+                    </a:solidFill>
+                  </a:tcPr>
+                </a:tc>
+              </a:tr>
+              <a:tr h="292608">
+                <a:tc>
+                  <a:txBody>
+                    <a:bodyPr wrap="square"/>
+                    <a:lstStyle/>
+                    <a:p>
+                      <a:r>
+                        <a:rPr sz="900" b="0">
+                          <a:solidFill>
+                            <a:srgbClr val="0B0B0B"/>
+                          </a:solidFill>
+                          <a:latin typeface="Calibri"/>
+                        </a:rPr>
+                        <a:t>XP CDI CRA FIAGRO RESPONSABILIDADE LIMITADA</a:t>
+                      </a:r>
+                    </a:p>
+                  </a:txBody>
+                  <a:tcPr>
+                    <a:solidFill>
+                      <a:srgbClr val="FFFFFF"/>
+                    </a:solidFill>
+                  </a:tcPr>
+                </a:tc>
+                <a:tc>
+                  <a:txBody>
+                    <a:bodyPr wrap="square"/>
+                    <a:lstStyle/>
+                    <a:p>
+                      <a:r>
+                        <a:rPr sz="900" b="0">
+                          <a:solidFill>
+                            <a:srgbClr val="0B0B0B"/>
+                          </a:solidFill>
+                          <a:latin typeface="Calibri"/>
+                        </a:rPr>
+                        <a:t>XP Investimentos</a:t>
+                      </a:r>
+                    </a:p>
+                  </a:txBody>
+                  <a:tcPr>
+                    <a:solidFill>
+                      <a:srgbClr val="FFFFFF"/>
+                    </a:solidFill>
+                  </a:tcPr>
+                </a:tc>
+                <a:tc>
+                  <a:txBody>
+                    <a:bodyPr wrap="square"/>
+                    <a:lstStyle/>
+                    <a:p>
+                      <a:r>
+                        <a:rPr sz="900" b="0">
+                          <a:solidFill>
+                            <a:srgbClr val="0B0B0B"/>
+                          </a:solidFill>
+                          <a:latin typeface="Calibri"/>
+                        </a:rPr>
+                        <a:t>XP VISTA ASSET MANAGEMENT LTDA.</a:t>
+                      </a:r>
+                    </a:p>
+                  </a:txBody>
+                  <a:tcPr>
+                    <a:solidFill>
+                      <a:srgbClr val="FFFFFF"/>
+                    </a:solidFill>
+                  </a:tcPr>
+                </a:tc>
+                <a:tc>
+                  <a:txBody>
+                    <a:bodyPr wrap="square"/>
+                    <a:lstStyle/>
+                    <a:p>
+                      <a:r>
+                        <a:rPr sz="900" b="0">
+                          <a:solidFill>
+                            <a:srgbClr val="0B0B0B"/>
+                          </a:solidFill>
+                          <a:latin typeface="Calibri"/>
+                        </a:rPr>
+                        <a:t>2026-09-18</a:t>
+                      </a:r>
+                    </a:p>
+                  </a:txBody>
+                  <a:tcPr>
+                    <a:solidFill>
+                      <a:srgbClr val="FFFFFF"/>
+                    </a:solidFill>
+                  </a:tcPr>
+                </a:tc>
+              </a:tr>
+              <a:tr h="292608">
+                <a:tc>
+                  <a:txBody>
+                    <a:bodyPr wrap="square"/>
+                    <a:lstStyle/>
+                    <a:p>
+                      <a:r>
+                        <a:rPr sz="900" b="0">
+                          <a:solidFill>
+                            <a:srgbClr val="0B0B0B"/>
+                          </a:solidFill>
+                          <a:latin typeface="Calibri"/>
+                        </a:rPr>
+                        <a:t>INDIANA II FUNDO DE INVESTIMENTO FINANCEIRO MULTIMERCADO CRÉDITO PRIVA</a:t>
+                      </a:r>
+                    </a:p>
+                  </a:txBody>
+                  <a:tcPr>
+                    <a:solidFill>
+                      <a:srgbClr val="FFFFFF"/>
+                    </a:solidFill>
+                  </a:tcPr>
+                </a:tc>
+                <a:tc>
+                  <a:txBody>
+                    <a:bodyPr wrap="square"/>
+                    <a:lstStyle/>
+                    <a:p>
+                      <a:r>
+                        <a:rPr sz="900" b="0">
+                          <a:solidFill>
+                            <a:srgbClr val="0B0B0B"/>
+                          </a:solidFill>
+                          <a:latin typeface="Calibri"/>
+                        </a:rPr>
+                        <a:t>Itau (Ion)</a:t>
+                      </a:r>
+                    </a:p>
+                  </a:txBody>
+                  <a:tcPr>
+                    <a:solidFill>
+                      <a:srgbClr val="FFFFFF"/>
+                    </a:solidFill>
+                  </a:tcPr>
+                </a:tc>
+                <a:tc>
+                  <a:txBody>
+                    <a:bodyPr wrap="square"/>
+                    <a:lstStyle/>
+                    <a:p>
+                      <a:r>
+                        <a:rPr sz="900" b="0">
+                          <a:solidFill>
+                            <a:srgbClr val="0B0B0B"/>
+                          </a:solidFill>
+                          <a:latin typeface="Calibri"/>
+                        </a:rPr>
+                        <a:t>ITAU UNIBANCO ASSET MANAGEMENT LTDA.</a:t>
+                      </a:r>
+                    </a:p>
+                  </a:txBody>
+                  <a:tcPr>
+                    <a:solidFill>
+                      <a:srgbClr val="FFFFFF"/>
+                    </a:solidFill>
+                  </a:tcPr>
+                </a:tc>
+                <a:tc>
+                  <a:txBody>
+                    <a:bodyPr wrap="square"/>
+                    <a:lstStyle/>
+                    <a:p>
+                      <a:r>
+                        <a:rPr sz="900" b="0">
+                          <a:solidFill>
+                            <a:srgbClr val="0B0B0B"/>
+                          </a:solidFill>
+                          <a:latin typeface="Calibri"/>
+                        </a:rPr>
+                        <a:t>2026-09-18</a:t>
+                      </a:r>
+                    </a:p>
+                  </a:txBody>
+                  <a:tcPr>
+                    <a:solidFill>
+                      <a:srgbClr val="FFFFFF"/>
+                    </a:solidFill>
+                  </a:tcPr>
+                </a:tc>
+              </a:tr>
+              <a:tr h="292608">
+                <a:tc>
+                  <a:txBody>
+                    <a:bodyPr wrap="square"/>
+                    <a:lstStyle/>
+                    <a:p>
+                      <a:r>
+                        <a:rPr sz="900" b="0">
+                          <a:solidFill>
+                            <a:srgbClr val="0B0B0B"/>
+                          </a:solidFill>
+                          <a:latin typeface="Calibri"/>
+                        </a:rPr>
+                        <a:t>BTG PACTUAL FEEDER I FUNDO DE INVESTIMENTO FINANCEIRO MULTIMERCADO CRÉ</a:t>
+                      </a:r>
+                    </a:p>
+                  </a:txBody>
+                  <a:tcPr>
+                    <a:solidFill>
+                      <a:srgbClr val="FFFFFF"/>
+                    </a:solidFill>
+                  </a:tcPr>
+                </a:tc>
+                <a:tc>
+                  <a:txBody>
+                    <a:bodyPr wrap="square"/>
+                    <a:lstStyle/>
+                    <a:p>
+                      <a:r>
+                        <a:rPr sz="900" b="0">
+                          <a:solidFill>
+                            <a:srgbClr val="0B0B0B"/>
+                          </a:solidFill>
+                          <a:latin typeface="Calibri"/>
+                        </a:rPr>
+                        <a:t>BTG Pactual</a:t>
+                      </a:r>
+                    </a:p>
+                  </a:txBody>
+                  <a:tcPr>
+                    <a:solidFill>
+                      <a:srgbClr val="FFFFFF"/>
+                    </a:solidFill>
+                  </a:tcPr>
+                </a:tc>
+                <a:tc>
+                  <a:txBody>
+                    <a:bodyPr wrap="square"/>
+                    <a:lstStyle/>
+                    <a:p>
+                      <a:r>
+                        <a:rPr sz="900" b="0">
+                          <a:solidFill>
+                            <a:srgbClr val="0B0B0B"/>
+                          </a:solidFill>
+                          <a:latin typeface="Calibri"/>
+                        </a:rPr>
+                        <a:t>BTG PACTUAL ASSET MANAGEMENT S/A DTVM</a:t>
+                      </a:r>
+                    </a:p>
+                  </a:txBody>
+                  <a:tcPr>
+                    <a:solidFill>
+                      <a:srgbClr val="FFFFFF"/>
+                    </a:solidFill>
+                  </a:tcPr>
+                </a:tc>
+                <a:tc>
+                  <a:txBody>
+                    <a:bodyPr wrap="square"/>
+                    <a:lstStyle/>
+                    <a:p>
+                      <a:r>
+                        <a:rPr sz="900" b="0">
+                          <a:solidFill>
+                            <a:srgbClr val="0B0B0B"/>
+                          </a:solidFill>
+                          <a:latin typeface="Calibri"/>
+                        </a:rPr>
+                        <a:t>2026-09-18</a:t>
+                      </a:r>
+                    </a:p>
+                  </a:txBody>
+                  <a:tcPr>
+                    <a:solidFill>
+                      <a:srgbClr val="FFFFFF"/>
+                    </a:solidFill>
+                  </a:tcPr>
+                </a:tc>
+              </a:tr>
+              <a:tr h="292608">
+                <a:tc>
+                  <a:txBody>
+                    <a:bodyPr wrap="square"/>
+                    <a:lstStyle/>
+                    <a:p>
+                      <a:r>
+                        <a:rPr sz="900" b="0">
+                          <a:solidFill>
+                            <a:srgbClr val="0B0B0B"/>
+                          </a:solidFill>
+                          <a:latin typeface="Calibri"/>
+                        </a:rPr>
+                        <a:t>XP STRATEGY FI FINANCEIRO MULTIMERCADO CRÉDITO PRIVADO PREVIDENCIÁRIO </a:t>
+                      </a:r>
+                    </a:p>
+                  </a:txBody>
+                  <a:tcPr>
+                    <a:solidFill>
+                      <a:srgbClr val="FFFFFF"/>
+                    </a:solidFill>
+                  </a:tcPr>
+                </a:tc>
+                <a:tc>
+                  <a:txBody>
+                    <a:bodyPr wrap="square"/>
+                    <a:lstStyle/>
+                    <a:p>
+                      <a:r>
+                        <a:rPr sz="900" b="0">
+                          <a:solidFill>
+                            <a:srgbClr val="0B0B0B"/>
+                          </a:solidFill>
+                          <a:latin typeface="Calibri"/>
+                        </a:rPr>
+                        <a:t>XP Investimentos</a:t>
+                      </a:r>
+                    </a:p>
+                  </a:txBody>
+                  <a:tcPr>
+                    <a:solidFill>
+                      <a:srgbClr val="FFFFFF"/>
+                    </a:solidFill>
+                  </a:tcPr>
+                </a:tc>
+                <a:tc>
+                  <a:txBody>
+                    <a:bodyPr wrap="square"/>
+                    <a:lstStyle/>
+                    <a:p>
+                      <a:r>
+                        <a:rPr sz="900" b="0">
+                          <a:solidFill>
+                            <a:srgbClr val="0B0B0B"/>
+                          </a:solidFill>
+                          <a:latin typeface="Calibri"/>
+                        </a:rPr>
+                        <a:t>XP GESTÃO DE RECURSOS LTDA</a:t>
+                      </a:r>
+                    </a:p>
+                  </a:txBody>
+                  <a:tcPr>
+                    <a:solidFill>
+                      <a:srgbClr val="FFFFFF"/>
+                    </a:solidFill>
+                  </a:tcPr>
+                </a:tc>
+                <a:tc>
+                  <a:txBody>
+                    <a:bodyPr wrap="square"/>
+                    <a:lstStyle/>
+                    <a:p>
+                      <a:r>
+                        <a:rPr sz="900" b="0">
+                          <a:solidFill>
+                            <a:srgbClr val="0B0B0B"/>
+                          </a:solidFill>
+                          <a:latin typeface="Calibri"/>
+                        </a:rPr>
+                        <a:t>2026-09-18</a:t>
+                      </a:r>
+                    </a:p>
+                  </a:txBody>
+                  <a:tcPr>
+                    <a:solidFill>
+                      <a:srgbClr val="FFFFFF"/>
+                    </a:solidFill>
+                  </a:tcPr>
+                </a:tc>
+              </a:tr>
+            </a:tbl>
+          </a:graphicData>
+        </a:graphic>
+      </p:graphicFrame>
+    </p:spTree>
+  </p:cSld>
+  <p:clrMapOvr>
+    <a:masterClrMapping/>
+  </p:clrMapOvr>
+</p:sld>
+</file>
+
+<file path=ppt/slides/slide9.xml><?xml version="1.0" encoding="utf-8"?>
+<p:sld xmlns:a="http://schemas.openxmlformats.org/drawingml/2006/main" xmlns:p="http://schemas.openxmlformats.org/presentationml/2006/main" xmlns:r="http://schemas.openxmlformats.org/officeDocument/2006/relationships">
+  <p:cSld>
+    <p:spTree>
+      <p:nvGrpSpPr>
+        <p:cNvPr id="1" name=""/>
+        <p:cNvGrpSpPr/>
+        <p:nvPr/>
+      </p:nvGrpSpPr>
+      <p:grpSpPr/>
+      <p:sp>
+        <p:nvSpPr>
+          <p:cNvPr id="2" name="Rectangle 1"/>
+          <p:cNvSpPr/>
+          <p:nvPr/>
+        </p:nvSpPr>
+        <p:spPr>
+          <a:xfrm>
+            <a:off x="0" y="0"/>
+            <a:ext cx="12191695" cy="6858000"/>
+          </a:xfrm>
+          <a:prstGeom prst="rect">
+            <a:avLst/>
+          </a:prstGeom>
+          <a:solidFill>
+            <a:srgbClr val="FCFCFB"/>
+          </a:solidFill>
+          <a:ln>
+            <a:noFill/>
+          </a:ln>
+          <a:effectLst/>
+        </p:spPr>
+        <p:style>
+          <a:lnRef idx="1">
+            <a:schemeClr val="accent1"/>
+          </a:lnRef>
+          <a:fillRef idx="3">
+            <a:schemeClr val="accent1"/>
+          </a:fillRef>
+          <a:effectRef idx="2">
+            <a:schemeClr val="accent1"/>
+          </a:effectRef>
+          <a:fontRef idx="minor">
+            <a:schemeClr val="lt1"/>
+          </a:fontRef>
+        </p:style>
+        <p:txBody>
+          <a:bodyPr rtlCol="0" anchor="ctr"/>
+          <a:lstStyle/>
+          <a:p>
+            <a:pPr algn="ctr"/>
+          </a:p>
+        </p:txBody>
+      </p:sp>
+      <p:sp>
+        <p:nvSpPr>
+          <p:cNvPr id="3" name="TextBox 2"/>
+          <p:cNvSpPr txBox="1"/>
+          <p:nvPr/>
+        </p:nvSpPr>
+        <p:spPr>
+          <a:xfrm>
+            <a:off x="548640" y="320040"/>
+            <a:ext cx="11064240" cy="548640"/>
+          </a:xfrm>
+          <a:prstGeom prst="rect">
+            <a:avLst/>
+          </a:prstGeom>
+          <a:noFill/>
+        </p:spPr>
+        <p:txBody>
+          <a:bodyPr wrap="square">
+            <a:spAutoFit/>
+          </a:bodyPr>
+          <a:lstStyle/>
+          <a:p>
+            <a:r>
+              <a:rPr sz="2400" b="1">
+                <a:solidFill>
+                  <a:srgbClr val="0B0B0B"/>
+                </a:solidFill>
+                <a:latin typeface="Calibri"/>
+              </a:rPr>
               <a:t>Metodologia e proveniencia</a:t>
             </a:r>
           </a:p>
@@ -11092,7 +12350,7 @@
                 </a:solidFill>
                 <a:latin typeface="Calibri"/>
               </a:rPr>
-              <a:t>fundos exclusivos/restritos (3.616 nesta coleta) ficam fora de toda analise; o inventario deles esta na aba 'Restritos (auxiliar)' da planilha e no dashboard.</a:t>
+              <a:t>fundos exclusivos/restritos (3.602 nesta coleta) ficam fora de toda analise; o inventario deles esta na aba 'Restritos (auxiliar)' da planilha e no dashboard.</a:t>
             </a:r>
           </a:p>
         </p:txBody>
@@ -11228,7 +12486,7 @@
                 </a:solidFill>
                 <a:latin typeface="Calibri"/>
               </a:rPr>
-              <a:t>join com o registro oficial CVM por CNPJ e por codigo: 9200 de 13486 fundos identificaveis (68%); a gestora vem do registro em 9.199 deles.</a:t>
+              <a:t>join com o registro oficial CVM por CNPJ e por codigo: 9167 de 13486 fundos identificaveis (68%); a gestora vem do registro em 9.166 deles.</a:t>
             </a:r>
           </a:p>
         </p:txBody>
@@ -11296,7 +12554,7 @@
                 </a:solidFill>
                 <a:latin typeface="Calibri"/>
               </a:rPr>
-              <a:t>20/09/2026 - status ok; vitrine 668 de 781</a:t>
+              <a:t>20/09/2026 - status ok; vitrine 664 de 781</a:t>
             </a:r>
           </a:p>
         </p:txBody>
@@ -11364,7 +12622,7 @@
                 </a:solidFill>
                 <a:latin typeface="Calibri"/>
               </a:rPr>
-              <a:t>20/09/2026 - status ok; vitrine 660 de 10073</a:t>
+              <a:t>20/09/2026 - status ok; vitrine 634 de 10073</a:t>
             </a:r>
           </a:p>
         </p:txBody>
@@ -11432,7 +12690,7 @@
                 </a:solidFill>
                 <a:latin typeface="Calibri"/>
               </a:rPr>
-              <a:t>20/09/2026 - status ok; vitrine 459 de 2179</a:t>
+              <a:t>20/09/2026 - status ok; vitrine 458 de 2179</a:t>
             </a:r>
           </a:p>
         </p:txBody>

</xml_diff>